<commit_message>
multiple threads and flexible usage in ShareAllele.py
</commit_message>
<xml_diff>
--- a/lifeWebBasedSystemUserGuide.pptx
+++ b/lifeWebBasedSystemUserGuide.pptx
@@ -5,7 +5,7 @@
     <p:sldMasterId id="2147483648" r:id="rId1"/>
   </p:sldMasterIdLst>
   <p:notesMasterIdLst>
-    <p:notesMasterId r:id="rId29"/>
+    <p:notesMasterId r:id="rId30"/>
   </p:notesMasterIdLst>
   <p:sldIdLst>
     <p:sldId id="256" r:id="rId2"/>
@@ -35,6 +35,7 @@
     <p:sldId id="269" r:id="rId26"/>
     <p:sldId id="273" r:id="rId27"/>
     <p:sldId id="276" r:id="rId28"/>
+    <p:sldId id="283" r:id="rId29"/>
   </p:sldIdLst>
   <p:sldSz cx="9144000" cy="6858000" type="screen4x3"/>
   <p:notesSz cx="6858000" cy="9144000"/>
@@ -234,7 +235,7 @@
           <a:p>
             <a:fld id="{6D801948-0CEF-4CB3-AF4C-3EE6464C8881}" type="datetimeFigureOut">
               <a:rPr lang="zh-CN" altLang="en-US" smtClean="0"/>
-              <a:t>2018/3/28</a:t>
+              <a:t>2018/4/30</a:t>
             </a:fld>
             <a:endParaRPr lang="zh-CN" altLang="en-US"/>
           </a:p>
@@ -856,7 +857,7 @@
           <a:p>
             <a:fld id="{530820CF-B880-4189-942D-D702A7CBA730}" type="datetimeFigureOut">
               <a:rPr lang="zh-CN" altLang="en-US" smtClean="0"/>
-              <a:t>2018/3/28</a:t>
+              <a:t>2018/4/30</a:t>
             </a:fld>
             <a:endParaRPr lang="zh-CN" altLang="en-US"/>
           </a:p>
@@ -1019,7 +1020,7 @@
           <a:p>
             <a:fld id="{530820CF-B880-4189-942D-D702A7CBA730}" type="datetimeFigureOut">
               <a:rPr lang="zh-CN" altLang="en-US" smtClean="0"/>
-              <a:t>2018/3/28</a:t>
+              <a:t>2018/4/30</a:t>
             </a:fld>
             <a:endParaRPr lang="zh-CN" altLang="en-US"/>
           </a:p>
@@ -1192,7 +1193,7 @@
           <a:p>
             <a:fld id="{530820CF-B880-4189-942D-D702A7CBA730}" type="datetimeFigureOut">
               <a:rPr lang="zh-CN" altLang="en-US" smtClean="0"/>
-              <a:t>2018/3/28</a:t>
+              <a:t>2018/4/30</a:t>
             </a:fld>
             <a:endParaRPr lang="zh-CN" altLang="en-US"/>
           </a:p>
@@ -1355,7 +1356,7 @@
           <a:p>
             <a:fld id="{530820CF-B880-4189-942D-D702A7CBA730}" type="datetimeFigureOut">
               <a:rPr lang="zh-CN" altLang="en-US" smtClean="0"/>
-              <a:t>2018/3/28</a:t>
+              <a:t>2018/4/30</a:t>
             </a:fld>
             <a:endParaRPr lang="zh-CN" altLang="en-US"/>
           </a:p>
@@ -1595,7 +1596,7 @@
           <a:p>
             <a:fld id="{530820CF-B880-4189-942D-D702A7CBA730}" type="datetimeFigureOut">
               <a:rPr lang="zh-CN" altLang="en-US" smtClean="0"/>
-              <a:t>2018/3/28</a:t>
+              <a:t>2018/4/30</a:t>
             </a:fld>
             <a:endParaRPr lang="zh-CN" altLang="en-US"/>
           </a:p>
@@ -1875,7 +1876,7 @@
           <a:p>
             <a:fld id="{530820CF-B880-4189-942D-D702A7CBA730}" type="datetimeFigureOut">
               <a:rPr lang="zh-CN" altLang="en-US" smtClean="0"/>
-              <a:t>2018/3/28</a:t>
+              <a:t>2018/4/30</a:t>
             </a:fld>
             <a:endParaRPr lang="zh-CN" altLang="en-US"/>
           </a:p>
@@ -2289,7 +2290,7 @@
           <a:p>
             <a:fld id="{530820CF-B880-4189-942D-D702A7CBA730}" type="datetimeFigureOut">
               <a:rPr lang="zh-CN" altLang="en-US" smtClean="0"/>
-              <a:t>2018/3/28</a:t>
+              <a:t>2018/4/30</a:t>
             </a:fld>
             <a:endParaRPr lang="zh-CN" altLang="en-US"/>
           </a:p>
@@ -2401,7 +2402,7 @@
           <a:p>
             <a:fld id="{530820CF-B880-4189-942D-D702A7CBA730}" type="datetimeFigureOut">
               <a:rPr lang="zh-CN" altLang="en-US" smtClean="0"/>
-              <a:t>2018/3/28</a:t>
+              <a:t>2018/4/30</a:t>
             </a:fld>
             <a:endParaRPr lang="zh-CN" altLang="en-US"/>
           </a:p>
@@ -2491,7 +2492,7 @@
           <a:p>
             <a:fld id="{530820CF-B880-4189-942D-D702A7CBA730}" type="datetimeFigureOut">
               <a:rPr lang="zh-CN" altLang="en-US" smtClean="0"/>
-              <a:t>2018/3/28</a:t>
+              <a:t>2018/4/30</a:t>
             </a:fld>
             <a:endParaRPr lang="zh-CN" altLang="en-US"/>
           </a:p>
@@ -2761,7 +2762,7 @@
           <a:p>
             <a:fld id="{530820CF-B880-4189-942D-D702A7CBA730}" type="datetimeFigureOut">
               <a:rPr lang="zh-CN" altLang="en-US" smtClean="0"/>
-              <a:t>2018/3/28</a:t>
+              <a:t>2018/4/30</a:t>
             </a:fld>
             <a:endParaRPr lang="zh-CN" altLang="en-US"/>
           </a:p>
@@ -3008,7 +3009,7 @@
           <a:p>
             <a:fld id="{530820CF-B880-4189-942D-D702A7CBA730}" type="datetimeFigureOut">
               <a:rPr lang="zh-CN" altLang="en-US" smtClean="0"/>
-              <a:t>2018/3/28</a:t>
+              <a:t>2018/4/30</a:t>
             </a:fld>
             <a:endParaRPr lang="zh-CN" altLang="en-US"/>
           </a:p>
@@ -3214,7 +3215,7 @@
           <a:p>
             <a:fld id="{530820CF-B880-4189-942D-D702A7CBA730}" type="datetimeFigureOut">
               <a:rPr lang="zh-CN" altLang="en-US" smtClean="0"/>
-              <a:t>2018/3/28</a:t>
+              <a:t>2018/4/30</a:t>
             </a:fld>
             <a:endParaRPr lang="zh-CN" altLang="en-US"/>
           </a:p>
@@ -11199,6 +11200,253 @@
     <p:extLst>
       <p:ext uri="{BB962C8B-B14F-4D97-AF65-F5344CB8AC3E}">
         <p14:creationId xmlns:p14="http://schemas.microsoft.com/office/powerpoint/2010/main" val="1152856256"/>
+      </p:ext>
+    </p:extLst>
+  </p:cSld>
+  <p:clrMapOvr>
+    <a:masterClrMapping/>
+  </p:clrMapOvr>
+</p:sld>
+</file>
+
+<file path=ppt/slides/slide28.xml><?xml version="1.0" encoding="utf-8"?>
+<p:sld xmlns:a="http://schemas.openxmlformats.org/drawingml/2006/main" xmlns:r="http://schemas.openxmlformats.org/officeDocument/2006/relationships" xmlns:p="http://schemas.openxmlformats.org/presentationml/2006/main">
+  <p:cSld>
+    <p:spTree>
+      <p:nvGrpSpPr>
+        <p:cNvPr id="1" name=""/>
+        <p:cNvGrpSpPr/>
+        <p:nvPr/>
+      </p:nvGrpSpPr>
+      <p:grpSpPr>
+        <a:xfrm>
+          <a:off x="0" y="0"/>
+          <a:ext cx="0" cy="0"/>
+          <a:chOff x="0" y="0"/>
+          <a:chExt cx="0" cy="0"/>
+        </a:xfrm>
+      </p:grpSpPr>
+      <p:sp>
+        <p:nvSpPr>
+          <p:cNvPr id="2" name="标题 1">
+            <a:extLst>
+              <a:ext uri="{FF2B5EF4-FFF2-40B4-BE49-F238E27FC236}">
+                <a16:creationId xmlns:a16="http://schemas.microsoft.com/office/drawing/2014/main" id="{CB28488F-48AD-4143-A775-01288F071FF4}"/>
+              </a:ext>
+            </a:extLst>
+          </p:cNvPr>
+          <p:cNvSpPr>
+            <a:spLocks noGrp="1"/>
+          </p:cNvSpPr>
+          <p:nvPr>
+            <p:ph type="title"/>
+          </p:nvPr>
+        </p:nvSpPr>
+        <p:spPr/>
+        <p:txBody>
+          <a:bodyPr/>
+          <a:lstStyle/>
+          <a:p>
+            <a:r>
+              <a:rPr lang="en-US" altLang="zh-CN" dirty="0"/>
+              <a:t>ShareAllele.py </a:t>
+            </a:r>
+            <a:r>
+              <a:rPr lang="zh-CN" altLang="en-US" dirty="0"/>
+              <a:t>程序</a:t>
+            </a:r>
+          </a:p>
+        </p:txBody>
+      </p:sp>
+      <p:sp>
+        <p:nvSpPr>
+          <p:cNvPr id="3" name="内容占位符 2">
+            <a:extLst>
+              <a:ext uri="{FF2B5EF4-FFF2-40B4-BE49-F238E27FC236}">
+                <a16:creationId xmlns:a16="http://schemas.microsoft.com/office/drawing/2014/main" id="{AB833CD5-60FD-45F1-A336-C6E10BDC5559}"/>
+              </a:ext>
+            </a:extLst>
+          </p:cNvPr>
+          <p:cNvSpPr>
+            <a:spLocks noGrp="1"/>
+          </p:cNvSpPr>
+          <p:nvPr>
+            <p:ph idx="1"/>
+          </p:nvPr>
+        </p:nvSpPr>
+        <p:spPr/>
+        <p:txBody>
+          <a:bodyPr>
+            <a:normAutofit/>
+          </a:bodyPr>
+          <a:lstStyle/>
+          <a:p>
+            <a:r>
+              <a:rPr lang="en-US" altLang="zh-CN" sz="2400" dirty="0"/>
+              <a:t>-a --</a:t>
+            </a:r>
+            <a:r>
+              <a:rPr lang="en-US" altLang="zh-CN" sz="2400" dirty="0" err="1"/>
+              <a:t>archaicPopConfig</a:t>
+            </a:r>
+            <a:r>
+              <a:rPr lang="en-US" altLang="zh-CN" sz="2400" dirty="0"/>
+              <a:t> </a:t>
+            </a:r>
+            <a:r>
+              <a:rPr lang="zh-CN" altLang="en-US" sz="2400" dirty="0"/>
+              <a:t>为空，则只统计</a:t>
+            </a:r>
+            <a:r>
+              <a:rPr lang="en-US" altLang="zh-CN" sz="2400" dirty="0"/>
+              <a:t>BBAA</a:t>
+            </a:r>
+            <a:r>
+              <a:rPr lang="zh-CN" altLang="en-US" sz="2400" dirty="0"/>
+              <a:t>，</a:t>
+            </a:r>
+            <a:r>
+              <a:rPr lang="en-US" altLang="zh-CN" sz="2400" dirty="0"/>
+              <a:t>BABA,ABBA</a:t>
+            </a:r>
+            <a:r>
+              <a:rPr lang="zh-CN" altLang="en-US" sz="2400" dirty="0"/>
+              <a:t>等在</a:t>
+            </a:r>
+            <a:r>
+              <a:rPr lang="en-US" altLang="zh-CN" sz="2400" dirty="0"/>
+              <a:t>ΔAF</a:t>
+            </a:r>
+            <a:r>
+              <a:rPr lang="zh-CN" altLang="en-US" sz="2400" dirty="0"/>
+              <a:t>上的分布。并不生成</a:t>
+            </a:r>
+            <a:r>
+              <a:rPr lang="en-US" altLang="zh-CN" sz="2400" dirty="0" err="1"/>
+              <a:t>joinSNP</a:t>
+            </a:r>
+            <a:r>
+              <a:rPr lang="en-US" altLang="zh-CN" sz="2400" dirty="0"/>
+              <a:t> </a:t>
+            </a:r>
+            <a:r>
+              <a:rPr lang="zh-CN" altLang="en-US" sz="2400" dirty="0"/>
+              <a:t>文件</a:t>
+            </a:r>
+            <a:endParaRPr lang="en-US" altLang="zh-CN" sz="2400" dirty="0"/>
+          </a:p>
+          <a:p>
+            <a:r>
+              <a:rPr lang="en-US" altLang="zh-CN" sz="2400" dirty="0"/>
+              <a:t>-l –</a:t>
+            </a:r>
+            <a:r>
+              <a:rPr lang="en-US" altLang="zh-CN" sz="2400" dirty="0" err="1"/>
+              <a:t>filelist</a:t>
+            </a:r>
+            <a:r>
+              <a:rPr lang="en-US" altLang="zh-CN" sz="2400" dirty="0"/>
+              <a:t> </a:t>
+            </a:r>
+            <a:r>
+              <a:rPr lang="zh-CN" altLang="en-US" sz="2400" dirty="0"/>
+              <a:t>为空</a:t>
+            </a:r>
+            <a:r>
+              <a:rPr lang="en-US" altLang="zh-CN" sz="2400" dirty="0"/>
+              <a:t> –v --</a:t>
+            </a:r>
+            <a:r>
+              <a:rPr lang="en-US" altLang="zh-CN" sz="2400" dirty="0" err="1"/>
+              <a:t>snpfilelist</a:t>
+            </a:r>
+            <a:r>
+              <a:rPr lang="zh-CN" altLang="en-US" sz="2400" dirty="0"/>
+              <a:t>不为空则为标准状态，生成</a:t>
+            </a:r>
+            <a:r>
+              <a:rPr lang="en-US" altLang="zh-CN" sz="2400" dirty="0" err="1"/>
+              <a:t>joinSNP</a:t>
+            </a:r>
+            <a:r>
+              <a:rPr lang="zh-CN" altLang="en-US" sz="2400" dirty="0"/>
+              <a:t>文件，同时统计分布</a:t>
+            </a:r>
+            <a:endParaRPr lang="en-US" altLang="zh-CN" sz="2400" dirty="0"/>
+          </a:p>
+          <a:p>
+            <a:r>
+              <a:rPr lang="zh-CN" altLang="en-US" sz="2400" dirty="0"/>
+              <a:t>有一次 将程序改成多线程模式，</a:t>
+            </a:r>
+            <a:r>
+              <a:rPr lang="en-US" altLang="zh-CN" sz="2400" dirty="0" err="1"/>
+              <a:t>joinSNP</a:t>
+            </a:r>
+            <a:r>
+              <a:rPr lang="zh-CN" altLang="en-US" sz="2400" dirty="0"/>
+              <a:t>文件生成完成了，但是报错了，于是加了</a:t>
+            </a:r>
+            <a:r>
+              <a:rPr lang="en-US" altLang="zh-CN" sz="2400" dirty="0"/>
+              <a:t>-l –</a:t>
+            </a:r>
+            <a:r>
+              <a:rPr lang="en-US" altLang="zh-CN" sz="2400" dirty="0" err="1"/>
+              <a:t>filelist</a:t>
+            </a:r>
+            <a:r>
+              <a:rPr lang="en-US" altLang="zh-CN" sz="2400" dirty="0"/>
+              <a:t> </a:t>
+            </a:r>
+            <a:r>
+              <a:rPr lang="zh-CN" altLang="en-US" sz="2400" dirty="0"/>
+              <a:t>参数，读取标准模式下生成的文件前缀的列表文件，完成后续工作，即直接统计</a:t>
+            </a:r>
+            <a:r>
+              <a:rPr lang="en-US" altLang="zh-CN" sz="2400" dirty="0" err="1"/>
+              <a:t>joinSNP</a:t>
+            </a:r>
+            <a:r>
+              <a:rPr lang="zh-CN" altLang="en-US" sz="2400" dirty="0"/>
+              <a:t>文件（跳过已完成的</a:t>
+            </a:r>
+            <a:r>
+              <a:rPr lang="en-US" altLang="zh-CN" sz="2400" dirty="0"/>
+              <a:t>join</a:t>
+            </a:r>
+            <a:r>
+              <a:rPr lang="zh-CN" altLang="en-US" sz="2400" dirty="0"/>
+              <a:t>操作）得到</a:t>
+            </a:r>
+            <a:r>
+              <a:rPr lang="en-US" altLang="zh-CN" sz="2400" dirty="0" err="1"/>
+              <a:t>FreqStratifiedBBAA</a:t>
+            </a:r>
+            <a:r>
+              <a:rPr lang="zh-CN" altLang="en-US" sz="2400" dirty="0"/>
+              <a:t>的</a:t>
+            </a:r>
+            <a:r>
+              <a:rPr lang="en-US" altLang="zh-CN" sz="2400" dirty="0"/>
+              <a:t>dump</a:t>
+            </a:r>
+            <a:r>
+              <a:rPr lang="zh-CN" altLang="en-US" sz="2400" dirty="0"/>
+              <a:t>文件，在得到最终的分布数据文件</a:t>
+            </a:r>
+            <a:r>
+              <a:rPr lang="en-US" altLang="zh-CN" sz="2400"/>
+              <a:t>total.FreqStratifiedBBAA</a:t>
+            </a:r>
+            <a:endParaRPr lang="zh-CN" altLang="en-US" sz="2400" dirty="0"/>
+          </a:p>
+        </p:txBody>
+      </p:sp>
+    </p:spTree>
+    <p:extLst>
+      <p:ext uri="{BB962C8B-B14F-4D97-AF65-F5344CB8AC3E}">
+        <p14:creationId xmlns:p14="http://schemas.microsoft.com/office/powerpoint/2010/main" val="4282859034"/>
       </p:ext>
     </p:extLst>
   </p:cSld>

</xml_diff>

<commit_message>
modified a bug when produce Stratifiedfstdxybydaf, Stratifiedfstdxybyabsdaf file ,previous fstvalue is sum not average
</commit_message>
<xml_diff>
--- a/lifeWebBasedSystemUserGuide.pptx
+++ b/lifeWebBasedSystemUserGuide.pptx
@@ -235,7 +235,7 @@
           <a:p>
             <a:fld id="{6D801948-0CEF-4CB3-AF4C-3EE6464C8881}" type="datetimeFigureOut">
               <a:rPr lang="zh-CN" altLang="en-US" smtClean="0"/>
-              <a:t>2018/4/30</a:t>
+              <a:t>2018/6/2</a:t>
             </a:fld>
             <a:endParaRPr lang="zh-CN" altLang="en-US"/>
           </a:p>
@@ -857,7 +857,7 @@
           <a:p>
             <a:fld id="{530820CF-B880-4189-942D-D702A7CBA730}" type="datetimeFigureOut">
               <a:rPr lang="zh-CN" altLang="en-US" smtClean="0"/>
-              <a:t>2018/4/30</a:t>
+              <a:t>2018/6/2</a:t>
             </a:fld>
             <a:endParaRPr lang="zh-CN" altLang="en-US"/>
           </a:p>
@@ -1020,7 +1020,7 @@
           <a:p>
             <a:fld id="{530820CF-B880-4189-942D-D702A7CBA730}" type="datetimeFigureOut">
               <a:rPr lang="zh-CN" altLang="en-US" smtClean="0"/>
-              <a:t>2018/4/30</a:t>
+              <a:t>2018/6/2</a:t>
             </a:fld>
             <a:endParaRPr lang="zh-CN" altLang="en-US"/>
           </a:p>
@@ -1193,7 +1193,7 @@
           <a:p>
             <a:fld id="{530820CF-B880-4189-942D-D702A7CBA730}" type="datetimeFigureOut">
               <a:rPr lang="zh-CN" altLang="en-US" smtClean="0"/>
-              <a:t>2018/4/30</a:t>
+              <a:t>2018/6/2</a:t>
             </a:fld>
             <a:endParaRPr lang="zh-CN" altLang="en-US"/>
           </a:p>
@@ -1356,7 +1356,7 @@
           <a:p>
             <a:fld id="{530820CF-B880-4189-942D-D702A7CBA730}" type="datetimeFigureOut">
               <a:rPr lang="zh-CN" altLang="en-US" smtClean="0"/>
-              <a:t>2018/4/30</a:t>
+              <a:t>2018/6/2</a:t>
             </a:fld>
             <a:endParaRPr lang="zh-CN" altLang="en-US"/>
           </a:p>
@@ -1596,7 +1596,7 @@
           <a:p>
             <a:fld id="{530820CF-B880-4189-942D-D702A7CBA730}" type="datetimeFigureOut">
               <a:rPr lang="zh-CN" altLang="en-US" smtClean="0"/>
-              <a:t>2018/4/30</a:t>
+              <a:t>2018/6/2</a:t>
             </a:fld>
             <a:endParaRPr lang="zh-CN" altLang="en-US"/>
           </a:p>
@@ -1876,7 +1876,7 @@
           <a:p>
             <a:fld id="{530820CF-B880-4189-942D-D702A7CBA730}" type="datetimeFigureOut">
               <a:rPr lang="zh-CN" altLang="en-US" smtClean="0"/>
-              <a:t>2018/4/30</a:t>
+              <a:t>2018/6/2</a:t>
             </a:fld>
             <a:endParaRPr lang="zh-CN" altLang="en-US"/>
           </a:p>
@@ -2290,7 +2290,7 @@
           <a:p>
             <a:fld id="{530820CF-B880-4189-942D-D702A7CBA730}" type="datetimeFigureOut">
               <a:rPr lang="zh-CN" altLang="en-US" smtClean="0"/>
-              <a:t>2018/4/30</a:t>
+              <a:t>2018/6/2</a:t>
             </a:fld>
             <a:endParaRPr lang="zh-CN" altLang="en-US"/>
           </a:p>
@@ -2402,7 +2402,7 @@
           <a:p>
             <a:fld id="{530820CF-B880-4189-942D-D702A7CBA730}" type="datetimeFigureOut">
               <a:rPr lang="zh-CN" altLang="en-US" smtClean="0"/>
-              <a:t>2018/4/30</a:t>
+              <a:t>2018/6/2</a:t>
             </a:fld>
             <a:endParaRPr lang="zh-CN" altLang="en-US"/>
           </a:p>
@@ -2492,7 +2492,7 @@
           <a:p>
             <a:fld id="{530820CF-B880-4189-942D-D702A7CBA730}" type="datetimeFigureOut">
               <a:rPr lang="zh-CN" altLang="en-US" smtClean="0"/>
-              <a:t>2018/4/30</a:t>
+              <a:t>2018/6/2</a:t>
             </a:fld>
             <a:endParaRPr lang="zh-CN" altLang="en-US"/>
           </a:p>
@@ -2762,7 +2762,7 @@
           <a:p>
             <a:fld id="{530820CF-B880-4189-942D-D702A7CBA730}" type="datetimeFigureOut">
               <a:rPr lang="zh-CN" altLang="en-US" smtClean="0"/>
-              <a:t>2018/4/30</a:t>
+              <a:t>2018/6/2</a:t>
             </a:fld>
             <a:endParaRPr lang="zh-CN" altLang="en-US"/>
           </a:p>
@@ -3009,7 +3009,7 @@
           <a:p>
             <a:fld id="{530820CF-B880-4189-942D-D702A7CBA730}" type="datetimeFigureOut">
               <a:rPr lang="zh-CN" altLang="en-US" smtClean="0"/>
-              <a:t>2018/4/30</a:t>
+              <a:t>2018/6/2</a:t>
             </a:fld>
             <a:endParaRPr lang="zh-CN" altLang="en-US"/>
           </a:p>
@@ -3215,7 +3215,7 @@
           <a:p>
             <a:fld id="{530820CF-B880-4189-942D-D702A7CBA730}" type="datetimeFigureOut">
               <a:rPr lang="zh-CN" altLang="en-US" smtClean="0"/>
-              <a:t>2018/4/30</a:t>
+              <a:t>2018/6/2</a:t>
             </a:fld>
             <a:endParaRPr lang="zh-CN" altLang="en-US"/>
           </a:p>
@@ -11277,7 +11277,7 @@
         <p:spPr/>
         <p:txBody>
           <a:bodyPr>
-            <a:normAutofit/>
+            <a:normAutofit fontScale="92500" lnSpcReduction="10000"/>
           </a:bodyPr>
           <a:lstStyle/>
           <a:p>
@@ -11436,10 +11436,71 @@
               <a:t>文件，在得到最终的分布数据文件</a:t>
             </a:r>
             <a:r>
-              <a:rPr lang="en-US" altLang="zh-CN" sz="2400"/>
+              <a:rPr lang="en-US" altLang="zh-CN" sz="2400" dirty="0" err="1"/>
               <a:t>total.FreqStratifiedBBAA</a:t>
             </a:r>
-            <a:endParaRPr lang="zh-CN" altLang="en-US" sz="2400" dirty="0"/>
+            <a:endParaRPr lang="en-US" altLang="zh-CN" sz="2400" dirty="0"/>
+          </a:p>
+          <a:p>
+            <a:r>
+              <a:rPr lang="en-US" altLang="zh-CN" sz="2600" dirty="0" err="1"/>
+              <a:t>travelCountjoinWg</a:t>
+            </a:r>
+            <a:r>
+              <a:rPr lang="en-US" altLang="zh-CN" sz="2600" dirty="0"/>
+              <a:t> </a:t>
+            </a:r>
+            <a:r>
+              <a:rPr lang="zh-CN" altLang="en-US" sz="2600" dirty="0"/>
+              <a:t>方式生成的 </a:t>
+            </a:r>
+            <a:r>
+              <a:rPr lang="en-US" altLang="zh-CN" sz="2600" dirty="0" err="1"/>
+              <a:t>FreqStratifiedBBAA</a:t>
+            </a:r>
+            <a:r>
+              <a:rPr lang="zh-CN" altLang="en-US" sz="2600" dirty="0"/>
+              <a:t>文件最正确。</a:t>
+            </a:r>
+            <a:endParaRPr lang="en-US" altLang="zh-CN" sz="2600" dirty="0"/>
+          </a:p>
+          <a:p>
+            <a:r>
+              <a:rPr lang="en-US" altLang="zh-CN" sz="2600" dirty="0" err="1"/>
+              <a:t>countJoinFile</a:t>
+            </a:r>
+            <a:r>
+              <a:rPr lang="en-US" altLang="zh-CN" sz="2600" dirty="0"/>
+              <a:t> </a:t>
+            </a:r>
+            <a:r>
+              <a:rPr lang="zh-CN" altLang="en-US" sz="2600" dirty="0"/>
+              <a:t>和</a:t>
+            </a:r>
+            <a:r>
+              <a:rPr lang="en-US" altLang="zh-CN" sz="2600" dirty="0" err="1"/>
+              <a:t>travelCountjoinWg</a:t>
+            </a:r>
+            <a:r>
+              <a:rPr lang="zh-CN" altLang="en-US" sz="2600" dirty="0"/>
+              <a:t>生成的</a:t>
+            </a:r>
+            <a:r>
+              <a:rPr lang="en-US" altLang="zh-CN" sz="2600" dirty="0" err="1"/>
+              <a:t>joinSNP</a:t>
+            </a:r>
+            <a:r>
+              <a:rPr lang="zh-CN" altLang="en-US" sz="2600" dirty="0"/>
+              <a:t>最终</a:t>
+            </a:r>
+            <a:r>
+              <a:rPr lang="en-US" altLang="zh-CN" sz="2600" dirty="0"/>
+              <a:t>merge</a:t>
+            </a:r>
+            <a:r>
+              <a:rPr lang="zh-CN" altLang="en-US" sz="2600" dirty="0"/>
+              <a:t>文件应该是等效的。</a:t>
+            </a:r>
           </a:p>
         </p:txBody>
       </p:sp>

</xml_diff>

<commit_message>
correct the approach to detect ancient selection
</commit_message>
<xml_diff>
--- a/lifeWebBasedSystemUserGuide.pptx
+++ b/lifeWebBasedSystemUserGuide.pptx
@@ -235,7 +235,7 @@
           <a:p>
             <a:fld id="{6D801948-0CEF-4CB3-AF4C-3EE6464C8881}" type="datetimeFigureOut">
               <a:rPr lang="zh-CN" altLang="en-US" smtClean="0"/>
-              <a:t>2018/5/1</a:t>
+              <a:t>2019/11/26</a:t>
             </a:fld>
             <a:endParaRPr lang="zh-CN" altLang="en-US"/>
           </a:p>
@@ -678,6 +678,227 @@
 </p:notes>
 </file>
 
+<file path=ppt/notesSlides/notesSlide3.xml><?xml version="1.0" encoding="utf-8"?>
+<p:notes xmlns:a="http://schemas.openxmlformats.org/drawingml/2006/main" xmlns:r="http://schemas.openxmlformats.org/officeDocument/2006/relationships" xmlns:p="http://schemas.openxmlformats.org/presentationml/2006/main">
+  <p:cSld>
+    <p:spTree>
+      <p:nvGrpSpPr>
+        <p:cNvPr id="1" name=""/>
+        <p:cNvGrpSpPr/>
+        <p:nvPr/>
+      </p:nvGrpSpPr>
+      <p:grpSpPr>
+        <a:xfrm>
+          <a:off x="0" y="0"/>
+          <a:ext cx="0" cy="0"/>
+          <a:chOff x="0" y="0"/>
+          <a:chExt cx="0" cy="0"/>
+        </a:xfrm>
+      </p:grpSpPr>
+      <p:sp>
+        <p:nvSpPr>
+          <p:cNvPr id="2" name="幻灯片图像占位符 1"/>
+          <p:cNvSpPr>
+            <a:spLocks noGrp="1" noRot="1" noChangeAspect="1"/>
+          </p:cNvSpPr>
+          <p:nvPr>
+            <p:ph type="sldImg"/>
+          </p:nvPr>
+        </p:nvSpPr>
+        <p:spPr/>
+      </p:sp>
+      <p:sp>
+        <p:nvSpPr>
+          <p:cNvPr id="3" name="备注占位符 2"/>
+          <p:cNvSpPr>
+            <a:spLocks noGrp="1"/>
+          </p:cNvSpPr>
+          <p:nvPr>
+            <p:ph type="body" idx="1"/>
+          </p:nvPr>
+        </p:nvSpPr>
+        <p:spPr/>
+        <p:txBody>
+          <a:bodyPr/>
+          <a:lstStyle/>
+          <a:p>
+            <a:r>
+              <a:rPr lang="zh-CN" altLang="en-US" sz="1200" i="1" u="sng" kern="1200" dirty="0">
+                <a:solidFill>
+                  <a:schemeClr val="tx1"/>
+                </a:solidFill>
+                <a:latin typeface="+mn-lt"/>
+                <a:ea typeface="+mn-ea"/>
+                <a:cs typeface="+mn-cs"/>
+              </a:rPr>
+              <a:t>虽然 </a:t>
+            </a:r>
+            <a:r>
+              <a:rPr lang="en-US" altLang="zh-CN" sz="1200" dirty="0" err="1"/>
+              <a:t>dynamicInsertUpdateAncestralContext</a:t>
+            </a:r>
+            <a:r>
+              <a:rPr lang="zh-CN" altLang="en-US" sz="1200" dirty="0"/>
+              <a:t>对象的</a:t>
+            </a:r>
+            <a:r>
+              <a:rPr lang="en-US" altLang="zh-CN" sz="1200" b="1" dirty="0" err="1"/>
+              <a:t>insertorUpdatetopleveltable</a:t>
+            </a:r>
+            <a:r>
+              <a:rPr lang="en-US" altLang="zh-CN" sz="1200" b="1" dirty="0"/>
+              <a:t> </a:t>
+            </a:r>
+            <a:r>
+              <a:rPr lang="en-US" altLang="zh-CN" sz="1200" i="1" u="sng" kern="1200" dirty="0">
+                <a:solidFill>
+                  <a:schemeClr val="tx1"/>
+                </a:solidFill>
+                <a:latin typeface="+mn-lt"/>
+                <a:ea typeface="+mn-ea"/>
+                <a:cs typeface="+mn-cs"/>
+              </a:rPr>
+              <a:t>fill context or/and ancestral (using </a:t>
+            </a:r>
+            <a:r>
+              <a:rPr lang="en-US" altLang="zh-CN" sz="1200" i="1" u="sng" kern="1200" dirty="0" err="1">
+                <a:solidFill>
+                  <a:schemeClr val="tx1"/>
+                </a:solidFill>
+                <a:latin typeface="+mn-lt"/>
+                <a:ea typeface="+mn-ea"/>
+                <a:cs typeface="+mn-cs"/>
+              </a:rPr>
+              <a:t>outgroupVCFBAMconfig_beijingref</a:t>
+            </a:r>
+            <a:r>
+              <a:rPr lang="en-US" altLang="zh-CN" sz="1200" i="1" u="sng" kern="1200" dirty="0">
+                <a:solidFill>
+                  <a:schemeClr val="tx1"/>
+                </a:solidFill>
+                <a:latin typeface="+mn-lt"/>
+                <a:ea typeface="+mn-ea"/>
+                <a:cs typeface="+mn-cs"/>
+              </a:rPr>
+              <a:t> in </a:t>
+            </a:r>
+            <a:r>
+              <a:rPr lang="en-US" altLang="zh-CN" sz="1200" i="1" u="sng" kern="1200" dirty="0" err="1">
+                <a:solidFill>
+                  <a:schemeClr val="tx1"/>
+                </a:solidFill>
+                <a:latin typeface="+mn-lt"/>
+                <a:ea typeface="+mn-ea"/>
+                <a:cs typeface="+mn-cs"/>
+              </a:rPr>
+              <a:t>config.properties</a:t>
+            </a:r>
+            <a:r>
+              <a:rPr lang="en-US" altLang="zh-CN" sz="1200" i="1" u="sng" kern="1200" dirty="0">
+                <a:solidFill>
+                  <a:schemeClr val="tx1"/>
+                </a:solidFill>
+                <a:latin typeface="+mn-lt"/>
+                <a:ea typeface="+mn-ea"/>
+                <a:cs typeface="+mn-cs"/>
+              </a:rPr>
+              <a:t>)  </a:t>
+            </a:r>
+            <a:r>
+              <a:rPr lang="zh-CN" altLang="en-US" sz="1200" i="1" u="sng" kern="1200" dirty="0">
+                <a:solidFill>
+                  <a:schemeClr val="tx1"/>
+                </a:solidFill>
+                <a:latin typeface="+mn-lt"/>
+                <a:ea typeface="+mn-ea"/>
+                <a:cs typeface="+mn-cs"/>
+              </a:rPr>
+              <a:t>但是对于已有</a:t>
+            </a:r>
+            <a:r>
+              <a:rPr lang="en-US" altLang="zh-CN" sz="1200" i="1" u="sng" kern="1200" dirty="0">
+                <a:solidFill>
+                  <a:schemeClr val="tx1"/>
+                </a:solidFill>
+                <a:latin typeface="+mn-lt"/>
+                <a:ea typeface="+mn-ea"/>
+                <a:cs typeface="+mn-cs"/>
+              </a:rPr>
+              <a:t>SNP</a:t>
+            </a:r>
+            <a:r>
+              <a:rPr lang="zh-CN" altLang="en-US" sz="1200" i="1" u="sng" kern="1200" dirty="0">
+                <a:solidFill>
+                  <a:schemeClr val="tx1"/>
+                </a:solidFill>
+                <a:latin typeface="+mn-lt"/>
+                <a:ea typeface="+mn-ea"/>
+                <a:cs typeface="+mn-cs"/>
+              </a:rPr>
+              <a:t>但是没有</a:t>
+            </a:r>
+            <a:r>
+              <a:rPr lang="en-US" altLang="zh-CN" sz="1200" i="1" u="sng" kern="1200" dirty="0">
+                <a:solidFill>
+                  <a:schemeClr val="tx1"/>
+                </a:solidFill>
+                <a:latin typeface="+mn-lt"/>
+                <a:ea typeface="+mn-ea"/>
+                <a:cs typeface="+mn-cs"/>
+              </a:rPr>
+              <a:t>context</a:t>
+            </a:r>
+            <a:r>
+              <a:rPr lang="zh-CN" altLang="en-US" sz="1200" i="1" u="sng" kern="1200" dirty="0">
+                <a:solidFill>
+                  <a:schemeClr val="tx1"/>
+                </a:solidFill>
+                <a:latin typeface="+mn-lt"/>
+                <a:ea typeface="+mn-ea"/>
+                <a:cs typeface="+mn-cs"/>
+              </a:rPr>
+              <a:t>的记录还是需要用</a:t>
+            </a:r>
+            <a:endParaRPr lang="zh-CN" altLang="en-US" dirty="0"/>
+          </a:p>
+        </p:txBody>
+      </p:sp>
+      <p:sp>
+        <p:nvSpPr>
+          <p:cNvPr id="4" name="灯片编号占位符 3"/>
+          <p:cNvSpPr>
+            <a:spLocks noGrp="1"/>
+          </p:cNvSpPr>
+          <p:nvPr>
+            <p:ph type="sldNum" sz="quarter" idx="5"/>
+          </p:nvPr>
+        </p:nvSpPr>
+        <p:spPr/>
+        <p:txBody>
+          <a:bodyPr/>
+          <a:lstStyle/>
+          <a:p>
+            <a:fld id="{E2BC516E-6407-445D-8A52-218467D01D1D}" type="slidenum">
+              <a:rPr lang="zh-CN" altLang="en-US" smtClean="0"/>
+              <a:t>22</a:t>
+            </a:fld>
+            <a:endParaRPr lang="zh-CN" altLang="en-US"/>
+          </a:p>
+        </p:txBody>
+      </p:sp>
+    </p:spTree>
+    <p:extLst>
+      <p:ext uri="{BB962C8B-B14F-4D97-AF65-F5344CB8AC3E}">
+        <p14:creationId xmlns:p14="http://schemas.microsoft.com/office/powerpoint/2010/main" val="52145340"/>
+      </p:ext>
+    </p:extLst>
+  </p:cSld>
+  <p:clrMapOvr>
+    <a:masterClrMapping/>
+  </p:clrMapOvr>
+</p:notes>
+</file>
+
 <file path=ppt/slideLayouts/slideLayout1.xml><?xml version="1.0" encoding="utf-8"?>
 <p:sldLayout xmlns:a="http://schemas.openxmlformats.org/drawingml/2006/main" xmlns:r="http://schemas.openxmlformats.org/officeDocument/2006/relationships" xmlns:p="http://schemas.openxmlformats.org/presentationml/2006/main" type="title" preserve="1">
   <p:cSld name="标题幻灯片">
@@ -857,7 +1078,7 @@
           <a:p>
             <a:fld id="{530820CF-B880-4189-942D-D702A7CBA730}" type="datetimeFigureOut">
               <a:rPr lang="zh-CN" altLang="en-US" smtClean="0"/>
-              <a:t>2018/5/1</a:t>
+              <a:t>2019/11/26</a:t>
             </a:fld>
             <a:endParaRPr lang="zh-CN" altLang="en-US"/>
           </a:p>
@@ -1020,7 +1241,7 @@
           <a:p>
             <a:fld id="{530820CF-B880-4189-942D-D702A7CBA730}" type="datetimeFigureOut">
               <a:rPr lang="zh-CN" altLang="en-US" smtClean="0"/>
-              <a:t>2018/5/1</a:t>
+              <a:t>2019/11/26</a:t>
             </a:fld>
             <a:endParaRPr lang="zh-CN" altLang="en-US"/>
           </a:p>
@@ -1193,7 +1414,7 @@
           <a:p>
             <a:fld id="{530820CF-B880-4189-942D-D702A7CBA730}" type="datetimeFigureOut">
               <a:rPr lang="zh-CN" altLang="en-US" smtClean="0"/>
-              <a:t>2018/5/1</a:t>
+              <a:t>2019/11/26</a:t>
             </a:fld>
             <a:endParaRPr lang="zh-CN" altLang="en-US"/>
           </a:p>
@@ -1356,7 +1577,7 @@
           <a:p>
             <a:fld id="{530820CF-B880-4189-942D-D702A7CBA730}" type="datetimeFigureOut">
               <a:rPr lang="zh-CN" altLang="en-US" smtClean="0"/>
-              <a:t>2018/5/1</a:t>
+              <a:t>2019/11/26</a:t>
             </a:fld>
             <a:endParaRPr lang="zh-CN" altLang="en-US"/>
           </a:p>
@@ -1596,7 +1817,7 @@
           <a:p>
             <a:fld id="{530820CF-B880-4189-942D-D702A7CBA730}" type="datetimeFigureOut">
               <a:rPr lang="zh-CN" altLang="en-US" smtClean="0"/>
-              <a:t>2018/5/1</a:t>
+              <a:t>2019/11/26</a:t>
             </a:fld>
             <a:endParaRPr lang="zh-CN" altLang="en-US"/>
           </a:p>
@@ -1876,7 +2097,7 @@
           <a:p>
             <a:fld id="{530820CF-B880-4189-942D-D702A7CBA730}" type="datetimeFigureOut">
               <a:rPr lang="zh-CN" altLang="en-US" smtClean="0"/>
-              <a:t>2018/5/1</a:t>
+              <a:t>2019/11/26</a:t>
             </a:fld>
             <a:endParaRPr lang="zh-CN" altLang="en-US"/>
           </a:p>
@@ -2290,7 +2511,7 @@
           <a:p>
             <a:fld id="{530820CF-B880-4189-942D-D702A7CBA730}" type="datetimeFigureOut">
               <a:rPr lang="zh-CN" altLang="en-US" smtClean="0"/>
-              <a:t>2018/5/1</a:t>
+              <a:t>2019/11/26</a:t>
             </a:fld>
             <a:endParaRPr lang="zh-CN" altLang="en-US"/>
           </a:p>
@@ -2402,7 +2623,7 @@
           <a:p>
             <a:fld id="{530820CF-B880-4189-942D-D702A7CBA730}" type="datetimeFigureOut">
               <a:rPr lang="zh-CN" altLang="en-US" smtClean="0"/>
-              <a:t>2018/5/1</a:t>
+              <a:t>2019/11/26</a:t>
             </a:fld>
             <a:endParaRPr lang="zh-CN" altLang="en-US"/>
           </a:p>
@@ -2492,7 +2713,7 @@
           <a:p>
             <a:fld id="{530820CF-B880-4189-942D-D702A7CBA730}" type="datetimeFigureOut">
               <a:rPr lang="zh-CN" altLang="en-US" smtClean="0"/>
-              <a:t>2018/5/1</a:t>
+              <a:t>2019/11/26</a:t>
             </a:fld>
             <a:endParaRPr lang="zh-CN" altLang="en-US"/>
           </a:p>
@@ -2762,7 +2983,7 @@
           <a:p>
             <a:fld id="{530820CF-B880-4189-942D-D702A7CBA730}" type="datetimeFigureOut">
               <a:rPr lang="zh-CN" altLang="en-US" smtClean="0"/>
-              <a:t>2018/5/1</a:t>
+              <a:t>2019/11/26</a:t>
             </a:fld>
             <a:endParaRPr lang="zh-CN" altLang="en-US"/>
           </a:p>
@@ -3009,7 +3230,7 @@
           <a:p>
             <a:fld id="{530820CF-B880-4189-942D-D702A7CBA730}" type="datetimeFigureOut">
               <a:rPr lang="zh-CN" altLang="en-US" smtClean="0"/>
-              <a:t>2018/5/1</a:t>
+              <a:t>2019/11/26</a:t>
             </a:fld>
             <a:endParaRPr lang="zh-CN" altLang="en-US"/>
           </a:p>
@@ -3215,7 +3436,7 @@
           <a:p>
             <a:fld id="{530820CF-B880-4189-942D-D702A7CBA730}" type="datetimeFigureOut">
               <a:rPr lang="zh-CN" altLang="en-US" smtClean="0"/>
-              <a:t>2018/5/1</a:t>
+              <a:t>2019/11/26</a:t>
             </a:fld>
             <a:endParaRPr lang="zh-CN" altLang="en-US"/>
           </a:p>
@@ -7904,7 +8125,7 @@
           </p:nvPr>
         </p:nvPicPr>
         <p:blipFill>
-          <a:blip r:embed="rId2">
+          <a:blip r:embed="rId3">
             <a:extLst>
               <a:ext uri="{28A0092B-C50C-407E-A947-70E740481C1C}">
                 <a14:useLocalDpi xmlns:a14="http://schemas.microsoft.com/office/drawing/2010/main" val="0"/>

</xml_diff>

<commit_message>
ancient selection bug fixed, MS is going to add reference may change the format or introduce some mistake
</commit_message>
<xml_diff>
--- a/lifeWebBasedSystemUserGuide.pptx
+++ b/lifeWebBasedSystemUserGuide.pptx
@@ -5,7 +5,7 @@
     <p:sldMasterId id="2147483648" r:id="rId1"/>
   </p:sldMasterIdLst>
   <p:notesMasterIdLst>
-    <p:notesMasterId r:id="rId30"/>
+    <p:notesMasterId r:id="rId31"/>
   </p:notesMasterIdLst>
   <p:sldIdLst>
     <p:sldId id="256" r:id="rId2"/>
@@ -30,12 +30,13 @@
     <p:sldId id="264" r:id="rId21"/>
     <p:sldId id="265" r:id="rId22"/>
     <p:sldId id="266" r:id="rId23"/>
-    <p:sldId id="267" r:id="rId24"/>
-    <p:sldId id="268" r:id="rId25"/>
-    <p:sldId id="269" r:id="rId26"/>
-    <p:sldId id="273" r:id="rId27"/>
-    <p:sldId id="276" r:id="rId28"/>
-    <p:sldId id="283" r:id="rId29"/>
+    <p:sldId id="284" r:id="rId24"/>
+    <p:sldId id="267" r:id="rId25"/>
+    <p:sldId id="268" r:id="rId26"/>
+    <p:sldId id="269" r:id="rId27"/>
+    <p:sldId id="273" r:id="rId28"/>
+    <p:sldId id="276" r:id="rId29"/>
+    <p:sldId id="283" r:id="rId30"/>
   </p:sldIdLst>
   <p:sldSz cx="9144000" cy="6858000" type="screen4x3"/>
   <p:notesSz cx="6858000" cy="9144000"/>
@@ -235,7 +236,7 @@
           <a:p>
             <a:fld id="{6D801948-0CEF-4CB3-AF4C-3EE6464C8881}" type="datetimeFigureOut">
               <a:rPr lang="zh-CN" altLang="en-US" smtClean="0"/>
-              <a:t>2019/11/28</a:t>
+              <a:t>2019/12/6</a:t>
             </a:fld>
             <a:endParaRPr lang="zh-CN" altLang="en-US"/>
           </a:p>
@@ -1100,7 +1101,7 @@
           <a:p>
             <a:fld id="{530820CF-B880-4189-942D-D702A7CBA730}" type="datetimeFigureOut">
               <a:rPr lang="zh-CN" altLang="en-US" smtClean="0"/>
-              <a:t>2019/11/28</a:t>
+              <a:t>2019/12/6</a:t>
             </a:fld>
             <a:endParaRPr lang="zh-CN" altLang="en-US"/>
           </a:p>
@@ -1263,7 +1264,7 @@
           <a:p>
             <a:fld id="{530820CF-B880-4189-942D-D702A7CBA730}" type="datetimeFigureOut">
               <a:rPr lang="zh-CN" altLang="en-US" smtClean="0"/>
-              <a:t>2019/11/28</a:t>
+              <a:t>2019/12/6</a:t>
             </a:fld>
             <a:endParaRPr lang="zh-CN" altLang="en-US"/>
           </a:p>
@@ -1436,7 +1437,7 @@
           <a:p>
             <a:fld id="{530820CF-B880-4189-942D-D702A7CBA730}" type="datetimeFigureOut">
               <a:rPr lang="zh-CN" altLang="en-US" smtClean="0"/>
-              <a:t>2019/11/28</a:t>
+              <a:t>2019/12/6</a:t>
             </a:fld>
             <a:endParaRPr lang="zh-CN" altLang="en-US"/>
           </a:p>
@@ -1599,7 +1600,7 @@
           <a:p>
             <a:fld id="{530820CF-B880-4189-942D-D702A7CBA730}" type="datetimeFigureOut">
               <a:rPr lang="zh-CN" altLang="en-US" smtClean="0"/>
-              <a:t>2019/11/28</a:t>
+              <a:t>2019/12/6</a:t>
             </a:fld>
             <a:endParaRPr lang="zh-CN" altLang="en-US"/>
           </a:p>
@@ -1839,7 +1840,7 @@
           <a:p>
             <a:fld id="{530820CF-B880-4189-942D-D702A7CBA730}" type="datetimeFigureOut">
               <a:rPr lang="zh-CN" altLang="en-US" smtClean="0"/>
-              <a:t>2019/11/28</a:t>
+              <a:t>2019/12/6</a:t>
             </a:fld>
             <a:endParaRPr lang="zh-CN" altLang="en-US"/>
           </a:p>
@@ -2119,7 +2120,7 @@
           <a:p>
             <a:fld id="{530820CF-B880-4189-942D-D702A7CBA730}" type="datetimeFigureOut">
               <a:rPr lang="zh-CN" altLang="en-US" smtClean="0"/>
-              <a:t>2019/11/28</a:t>
+              <a:t>2019/12/6</a:t>
             </a:fld>
             <a:endParaRPr lang="zh-CN" altLang="en-US"/>
           </a:p>
@@ -2533,7 +2534,7 @@
           <a:p>
             <a:fld id="{530820CF-B880-4189-942D-D702A7CBA730}" type="datetimeFigureOut">
               <a:rPr lang="zh-CN" altLang="en-US" smtClean="0"/>
-              <a:t>2019/11/28</a:t>
+              <a:t>2019/12/6</a:t>
             </a:fld>
             <a:endParaRPr lang="zh-CN" altLang="en-US"/>
           </a:p>
@@ -2645,7 +2646,7 @@
           <a:p>
             <a:fld id="{530820CF-B880-4189-942D-D702A7CBA730}" type="datetimeFigureOut">
               <a:rPr lang="zh-CN" altLang="en-US" smtClean="0"/>
-              <a:t>2019/11/28</a:t>
+              <a:t>2019/12/6</a:t>
             </a:fld>
             <a:endParaRPr lang="zh-CN" altLang="en-US"/>
           </a:p>
@@ -2735,7 +2736,7 @@
           <a:p>
             <a:fld id="{530820CF-B880-4189-942D-D702A7CBA730}" type="datetimeFigureOut">
               <a:rPr lang="zh-CN" altLang="en-US" smtClean="0"/>
-              <a:t>2019/11/28</a:t>
+              <a:t>2019/12/6</a:t>
             </a:fld>
             <a:endParaRPr lang="zh-CN" altLang="en-US"/>
           </a:p>
@@ -3005,7 +3006,7 @@
           <a:p>
             <a:fld id="{530820CF-B880-4189-942D-D702A7CBA730}" type="datetimeFigureOut">
               <a:rPr lang="zh-CN" altLang="en-US" smtClean="0"/>
-              <a:t>2019/11/28</a:t>
+              <a:t>2019/12/6</a:t>
             </a:fld>
             <a:endParaRPr lang="zh-CN" altLang="en-US"/>
           </a:p>
@@ -3252,7 +3253,7 @@
           <a:p>
             <a:fld id="{530820CF-B880-4189-942D-D702A7CBA730}" type="datetimeFigureOut">
               <a:rPr lang="zh-CN" altLang="en-US" smtClean="0"/>
-              <a:t>2019/11/28</a:t>
+              <a:t>2019/12/6</a:t>
             </a:fld>
             <a:endParaRPr lang="zh-CN" altLang="en-US"/>
           </a:p>
@@ -3458,7 +3459,7 @@
           <a:p>
             <a:fld id="{530820CF-B880-4189-942D-D702A7CBA730}" type="datetimeFigureOut">
               <a:rPr lang="zh-CN" altLang="en-US" smtClean="0"/>
-              <a:t>2019/11/28</a:t>
+              <a:t>2019/12/6</a:t>
             </a:fld>
             <a:endParaRPr lang="zh-CN" altLang="en-US"/>
           </a:p>
@@ -8766,6 +8767,132 @@
       </p:grpSpPr>
       <p:sp>
         <p:nvSpPr>
+          <p:cNvPr id="2" name="标题 1">
+            <a:extLst>
+              <a:ext uri="{FF2B5EF4-FFF2-40B4-BE49-F238E27FC236}">
+                <a16:creationId xmlns:a16="http://schemas.microsoft.com/office/drawing/2014/main" id="{9A67BD22-6E4C-4722-8A60-572414C3C935}"/>
+              </a:ext>
+            </a:extLst>
+          </p:cNvPr>
+          <p:cNvSpPr>
+            <a:spLocks noGrp="1"/>
+          </p:cNvSpPr>
+          <p:nvPr>
+            <p:ph type="title"/>
+          </p:nvPr>
+        </p:nvSpPr>
+        <p:spPr/>
+        <p:txBody>
+          <a:bodyPr/>
+          <a:lstStyle/>
+          <a:p>
+            <a:r>
+              <a:rPr lang="zh-CN" altLang="en-US" dirty="0"/>
+              <a:t>取消</a:t>
+            </a:r>
+            <a:r>
+              <a:rPr lang="en-US" altLang="zh-CN" dirty="0"/>
+              <a:t>no covered</a:t>
+            </a:r>
+            <a:r>
+              <a:rPr lang="zh-CN" altLang="zh-CN" dirty="0"/>
+              <a:t>改为</a:t>
+            </a:r>
+            <a:r>
+              <a:rPr lang="en-US" altLang="zh-CN" dirty="0"/>
+              <a:t>0,0</a:t>
+            </a:r>
+            <a:endParaRPr lang="zh-CN" altLang="en-US" dirty="0"/>
+          </a:p>
+        </p:txBody>
+      </p:sp>
+      <p:sp>
+        <p:nvSpPr>
+          <p:cNvPr id="3" name="内容占位符 2">
+            <a:extLst>
+              <a:ext uri="{FF2B5EF4-FFF2-40B4-BE49-F238E27FC236}">
+                <a16:creationId xmlns:a16="http://schemas.microsoft.com/office/drawing/2014/main" id="{09B82796-DCB5-4A37-A652-A76932F377F7}"/>
+              </a:ext>
+            </a:extLst>
+          </p:cNvPr>
+          <p:cNvSpPr>
+            <a:spLocks noGrp="1"/>
+          </p:cNvSpPr>
+          <p:nvPr>
+            <p:ph idx="1"/>
+          </p:nvPr>
+        </p:nvSpPr>
+        <p:spPr/>
+        <p:txBody>
+          <a:bodyPr/>
+          <a:lstStyle/>
+          <a:p>
+            <a:endParaRPr lang="zh-CN" altLang="en-US"/>
+          </a:p>
+        </p:txBody>
+      </p:sp>
+      <p:pic>
+        <p:nvPicPr>
+          <p:cNvPr id="4" name="图片 3">
+            <a:extLst>
+              <a:ext uri="{FF2B5EF4-FFF2-40B4-BE49-F238E27FC236}">
+                <a16:creationId xmlns:a16="http://schemas.microsoft.com/office/drawing/2014/main" id="{B92E957D-3312-43B3-BB01-0243D5EAB1CF}"/>
+              </a:ext>
+            </a:extLst>
+          </p:cNvPr>
+          <p:cNvPicPr>
+            <a:picLocks noChangeAspect="1"/>
+          </p:cNvPicPr>
+          <p:nvPr/>
+        </p:nvPicPr>
+        <p:blipFill>
+          <a:blip r:embed="rId2"/>
+          <a:stretch>
+            <a:fillRect/>
+          </a:stretch>
+        </p:blipFill>
+        <p:spPr>
+          <a:xfrm>
+            <a:off x="21704" y="3744097"/>
+            <a:ext cx="9144000" cy="1513703"/>
+          </a:xfrm>
+          <a:prstGeom prst="rect">
+            <a:avLst/>
+          </a:prstGeom>
+        </p:spPr>
+      </p:pic>
+    </p:spTree>
+    <p:extLst>
+      <p:ext uri="{BB962C8B-B14F-4D97-AF65-F5344CB8AC3E}">
+        <p14:creationId xmlns:p14="http://schemas.microsoft.com/office/powerpoint/2010/main" val="2122536461"/>
+      </p:ext>
+    </p:extLst>
+  </p:cSld>
+  <p:clrMapOvr>
+    <a:masterClrMapping/>
+  </p:clrMapOvr>
+</p:sld>
+</file>
+
+<file path=ppt/slides/slide24.xml><?xml version="1.0" encoding="utf-8"?>
+<p:sld xmlns:a="http://schemas.openxmlformats.org/drawingml/2006/main" xmlns:r="http://schemas.openxmlformats.org/officeDocument/2006/relationships" xmlns:p="http://schemas.openxmlformats.org/presentationml/2006/main">
+  <p:cSld>
+    <p:spTree>
+      <p:nvGrpSpPr>
+        <p:cNvPr id="1" name=""/>
+        <p:cNvGrpSpPr/>
+        <p:nvPr/>
+      </p:nvGrpSpPr>
+      <p:grpSpPr>
+        <a:xfrm>
+          <a:off x="0" y="0"/>
+          <a:ext cx="0" cy="0"/>
+          <a:chOff x="0" y="0"/>
+          <a:chExt cx="0" cy="0"/>
+        </a:xfrm>
+      </p:grpSpPr>
+      <p:sp>
+        <p:nvSpPr>
           <p:cNvPr id="2" name="标题 1"/>
           <p:cNvSpPr>
             <a:spLocks noGrp="1"/>
@@ -9411,7 +9538,7 @@
 </p:sld>
 </file>
 
-<file path=ppt/slides/slide24.xml><?xml version="1.0" encoding="utf-8"?>
+<file path=ppt/slides/slide25.xml><?xml version="1.0" encoding="utf-8"?>
 <p:sld xmlns:a="http://schemas.openxmlformats.org/drawingml/2006/main" xmlns:r="http://schemas.openxmlformats.org/officeDocument/2006/relationships" xmlns:p="http://schemas.openxmlformats.org/presentationml/2006/main">
   <p:cSld>
     <p:spTree>
@@ -10160,7 +10287,7 @@
 </p:sld>
 </file>
 
-<file path=ppt/slides/slide25.xml><?xml version="1.0" encoding="utf-8"?>
+<file path=ppt/slides/slide26.xml><?xml version="1.0" encoding="utf-8"?>
 <p:sld xmlns:a="http://schemas.openxmlformats.org/drawingml/2006/main" xmlns:r="http://schemas.openxmlformats.org/officeDocument/2006/relationships" xmlns:p="http://schemas.openxmlformats.org/presentationml/2006/main">
   <p:cSld>
     <p:spTree>
@@ -10623,709 +10750,6 @@
 </p:sld>
 </file>
 
-<file path=ppt/slides/slide26.xml><?xml version="1.0" encoding="utf-8"?>
-<p:sld xmlns:a="http://schemas.openxmlformats.org/drawingml/2006/main" xmlns:r="http://schemas.openxmlformats.org/officeDocument/2006/relationships" xmlns:p="http://schemas.openxmlformats.org/presentationml/2006/main">
-  <p:cSld>
-    <p:spTree>
-      <p:nvGrpSpPr>
-        <p:cNvPr id="1" name=""/>
-        <p:cNvGrpSpPr/>
-        <p:nvPr/>
-      </p:nvGrpSpPr>
-      <p:grpSpPr>
-        <a:xfrm>
-          <a:off x="0" y="0"/>
-          <a:ext cx="0" cy="0"/>
-          <a:chOff x="0" y="0"/>
-          <a:chExt cx="0" cy="0"/>
-        </a:xfrm>
-      </p:grpSpPr>
-      <p:sp>
-        <p:nvSpPr>
-          <p:cNvPr id="2" name="标题 1"/>
-          <p:cNvSpPr>
-            <a:spLocks noGrp="1"/>
-          </p:cNvSpPr>
-          <p:nvPr>
-            <p:ph type="title"/>
-          </p:nvPr>
-        </p:nvSpPr>
-        <p:spPr/>
-        <p:txBody>
-          <a:bodyPr/>
-          <a:lstStyle/>
-          <a:p>
-            <a:r>
-              <a:rPr lang="en-US" altLang="zh-CN" sz="3200" dirty="0"/>
-              <a:t>overview</a:t>
-            </a:r>
-            <a:endParaRPr lang="zh-CN" altLang="en-US" sz="3200" dirty="0"/>
-          </a:p>
-        </p:txBody>
-      </p:sp>
-      <p:sp>
-        <p:nvSpPr>
-          <p:cNvPr id="3" name="内容占位符 2"/>
-          <p:cNvSpPr>
-            <a:spLocks noGrp="1"/>
-          </p:cNvSpPr>
-          <p:nvPr>
-            <p:ph idx="1"/>
-          </p:nvPr>
-        </p:nvSpPr>
-        <p:spPr>
-          <a:xfrm>
-            <a:off x="457200" y="1196752"/>
-            <a:ext cx="8229600" cy="5328592"/>
-          </a:xfrm>
-        </p:spPr>
-        <p:txBody>
-          <a:bodyPr>
-            <a:normAutofit/>
-          </a:bodyPr>
-          <a:lstStyle/>
-          <a:p>
-            <a:r>
-              <a:rPr lang="en-US" altLang="zh-CN" sz="2400" dirty="0"/>
-              <a:t>VCF variant annotation program</a:t>
-            </a:r>
-          </a:p>
-          <a:p>
-            <a:r>
-              <a:rPr lang="en-US" altLang="zh-CN" sz="2400" dirty="0"/>
-              <a:t>Classify SNPs according its location in intron, </a:t>
-            </a:r>
-            <a:r>
-              <a:rPr lang="en-US" altLang="zh-CN" sz="2400" dirty="0" err="1"/>
-              <a:t>utr</a:t>
-            </a:r>
-            <a:r>
-              <a:rPr lang="en-US" altLang="zh-CN" sz="2400" dirty="0"/>
-              <a:t>, </a:t>
-            </a:r>
-            <a:r>
-              <a:rPr lang="en-US" altLang="zh-CN" sz="2400" dirty="0" err="1"/>
-              <a:t>intergenetic</a:t>
-            </a:r>
-            <a:r>
-              <a:rPr lang="en-US" altLang="zh-CN" sz="2400" dirty="0"/>
-              <a:t> or synonymous and </a:t>
-            </a:r>
-            <a:r>
-              <a:rPr lang="en-US" altLang="zh-CN" sz="2400" dirty="0" err="1"/>
-              <a:t>nosynonymous</a:t>
-            </a:r>
-            <a:endParaRPr lang="en-US" altLang="zh-CN" sz="2400" dirty="0"/>
-          </a:p>
-          <a:p>
-            <a:r>
-              <a:rPr lang="en-US" altLang="zh-CN" sz="2400" dirty="0"/>
-              <a:t>Translate mutation CDS into mutation AA </a:t>
-            </a:r>
-            <a:r>
-              <a:rPr lang="en-US" altLang="zh-CN" sz="2400" dirty="0" err="1"/>
-              <a:t>seq</a:t>
-            </a:r>
-            <a:endParaRPr lang="zh-CN" altLang="en-US" sz="2400" dirty="0"/>
-          </a:p>
-        </p:txBody>
-      </p:sp>
-      <p:sp>
-        <p:nvSpPr>
-          <p:cNvPr id="4" name="TextBox 3"/>
-          <p:cNvSpPr txBox="1"/>
-          <p:nvPr/>
-        </p:nvSpPr>
-        <p:spPr>
-          <a:xfrm>
-            <a:off x="0" y="0"/>
-            <a:ext cx="9139472" cy="369332"/>
-          </a:xfrm>
-          <a:prstGeom prst="rect">
-            <a:avLst/>
-          </a:prstGeom>
-          <a:noFill/>
-        </p:spPr>
-        <p:txBody>
-          <a:bodyPr wrap="square" rtlCol="0">
-            <a:spAutoFit/>
-          </a:bodyPr>
-          <a:lstStyle/>
-          <a:p>
-            <a:r>
-              <a:rPr lang="en-US" altLang="zh-CN" dirty="0"/>
-              <a:t>CatalogSNP_getAAseq_CDSseq.py</a:t>
-            </a:r>
-            <a:endParaRPr lang="zh-CN" altLang="en-US" dirty="0"/>
-          </a:p>
-        </p:txBody>
-      </p:sp>
-      <p:sp>
-        <p:nvSpPr>
-          <p:cNvPr id="5" name="矩形 4"/>
-          <p:cNvSpPr/>
-          <p:nvPr/>
-        </p:nvSpPr>
-        <p:spPr>
-          <a:xfrm>
-            <a:off x="3399361" y="3816037"/>
-            <a:ext cx="1728192" cy="1152128"/>
-          </a:xfrm>
-          <a:prstGeom prst="rect">
-            <a:avLst/>
-          </a:prstGeom>
-          <a:solidFill>
-            <a:schemeClr val="accent1">
-              <a:alpha val="0"/>
-            </a:schemeClr>
-          </a:solidFill>
-        </p:spPr>
-        <p:style>
-          <a:lnRef idx="2">
-            <a:schemeClr val="accent1">
-              <a:shade val="50000"/>
-            </a:schemeClr>
-          </a:lnRef>
-          <a:fillRef idx="1">
-            <a:schemeClr val="accent1"/>
-          </a:fillRef>
-          <a:effectRef idx="0">
-            <a:schemeClr val="accent1"/>
-          </a:effectRef>
-          <a:fontRef idx="minor">
-            <a:schemeClr val="lt1"/>
-          </a:fontRef>
-        </p:style>
-        <p:txBody>
-          <a:bodyPr rtlCol="0" anchor="ctr"/>
-          <a:lstStyle/>
-          <a:p>
-            <a:pPr algn="ctr"/>
-            <a:r>
-              <a:rPr lang="en-US" altLang="zh-CN" dirty="0">
-                <a:solidFill>
-                  <a:schemeClr val="tx1"/>
-                </a:solidFill>
-              </a:rPr>
-              <a:t>CatalogSNP_withaaseq_cdsseq.py</a:t>
-            </a:r>
-            <a:endParaRPr lang="zh-CN" altLang="en-US" dirty="0">
-              <a:solidFill>
-                <a:schemeClr val="tx1"/>
-              </a:solidFill>
-            </a:endParaRPr>
-          </a:p>
-        </p:txBody>
-      </p:sp>
-      <p:sp>
-        <p:nvSpPr>
-          <p:cNvPr id="6" name="TextBox 5"/>
-          <p:cNvSpPr txBox="1"/>
-          <p:nvPr/>
-        </p:nvSpPr>
-        <p:spPr>
-          <a:xfrm>
-            <a:off x="0" y="2970232"/>
-            <a:ext cx="2928571" cy="4247317"/>
-          </a:xfrm>
-          <a:prstGeom prst="rect">
-            <a:avLst/>
-          </a:prstGeom>
-          <a:noFill/>
-        </p:spPr>
-        <p:txBody>
-          <a:bodyPr wrap="square" rtlCol="0">
-            <a:spAutoFit/>
-          </a:bodyPr>
-          <a:lstStyle/>
-          <a:p>
-            <a:r>
-              <a:rPr lang="en-US" altLang="zh-CN" dirty="0"/>
-              <a:t>-v SNPs </a:t>
-            </a:r>
-            <a:r>
-              <a:rPr lang="en-US" altLang="zh-CN" dirty="0" err="1"/>
-              <a:t>mysql</a:t>
-            </a:r>
-            <a:r>
-              <a:rPr lang="zh-CN" altLang="en-US" dirty="0"/>
-              <a:t> </a:t>
-            </a:r>
-            <a:r>
-              <a:rPr lang="en-US" altLang="zh-CN" dirty="0"/>
-              <a:t>table name</a:t>
-            </a:r>
-          </a:p>
-          <a:p>
-            <a:r>
-              <a:rPr lang="en-US" altLang="zh-CN" dirty="0"/>
-              <a:t>-V VCF file name</a:t>
-            </a:r>
-          </a:p>
-          <a:p>
-            <a:r>
-              <a:rPr lang="en-US" altLang="zh-CN" dirty="0"/>
-              <a:t>-r reference </a:t>
-            </a:r>
-            <a:r>
-              <a:rPr lang="en-US" altLang="zh-CN" dirty="0" err="1"/>
-              <a:t>fasta</a:t>
-            </a:r>
-            <a:r>
-              <a:rPr lang="en-US" altLang="zh-CN" dirty="0"/>
-              <a:t> file</a:t>
-            </a:r>
-          </a:p>
-          <a:p>
-            <a:r>
-              <a:rPr lang="en-US" altLang="zh-CN" dirty="0"/>
-              <a:t>-g GTF file</a:t>
-            </a:r>
-          </a:p>
-          <a:p>
-            <a:r>
-              <a:rPr lang="en-US" altLang="zh-CN" dirty="0"/>
-              <a:t>-o output path</a:t>
-            </a:r>
-          </a:p>
-          <a:p>
-            <a:r>
-              <a:rPr lang="en-US" altLang="zh-CN" dirty="0"/>
-              <a:t>-b bed</a:t>
-            </a:r>
-            <a:r>
-              <a:rPr lang="zh-CN" altLang="en-US" dirty="0"/>
-              <a:t> </a:t>
-            </a:r>
-            <a:r>
-              <a:rPr lang="en-US" altLang="zh-CN" dirty="0"/>
-              <a:t>file</a:t>
-            </a:r>
-            <a:r>
-              <a:rPr lang="zh-CN" altLang="en-US" dirty="0"/>
-              <a:t>（</a:t>
-            </a:r>
-            <a:r>
-              <a:rPr lang="en-US" altLang="zh-CN" dirty="0"/>
-              <a:t>…</a:t>
-            </a:r>
-            <a:r>
-              <a:rPr lang="en-US" altLang="zh-CN" dirty="0" err="1"/>
-              <a:t>ing</a:t>
-            </a:r>
-            <a:r>
-              <a:rPr lang="zh-CN" altLang="en-US" dirty="0"/>
-              <a:t>）</a:t>
-            </a:r>
-            <a:endParaRPr lang="en-US" altLang="zh-CN" dirty="0"/>
-          </a:p>
-          <a:p>
-            <a:r>
-              <a:rPr lang="en-US" altLang="zh-CN" dirty="0"/>
-              <a:t>-m min length of the scaffolds (for –v only)</a:t>
-            </a:r>
-          </a:p>
-          <a:p>
-            <a:r>
-              <a:rPr lang="en-US" altLang="zh-CN" dirty="0"/>
-              <a:t>-5,-3 define distance from the start/stop codon as 5’/3’ UTR, in the case UTR annotation are absent in GTF annotation </a:t>
-            </a:r>
-          </a:p>
-          <a:p>
-            <a:endParaRPr lang="en-US" altLang="zh-CN" dirty="0"/>
-          </a:p>
-          <a:p>
-            <a:endParaRPr lang="zh-CN" altLang="en-US" dirty="0"/>
-          </a:p>
-        </p:txBody>
-      </p:sp>
-      <p:sp>
-        <p:nvSpPr>
-          <p:cNvPr id="7" name="右大括号 6"/>
-          <p:cNvSpPr/>
-          <p:nvPr/>
-        </p:nvSpPr>
-        <p:spPr>
-          <a:xfrm>
-            <a:off x="2555776" y="3816037"/>
-            <a:ext cx="432048" cy="1152128"/>
-          </a:xfrm>
-          <a:prstGeom prst="rightBrace">
-            <a:avLst/>
-          </a:prstGeom>
-        </p:spPr>
-        <p:style>
-          <a:lnRef idx="1">
-            <a:schemeClr val="accent1"/>
-          </a:lnRef>
-          <a:fillRef idx="0">
-            <a:schemeClr val="accent1"/>
-          </a:fillRef>
-          <a:effectRef idx="0">
-            <a:schemeClr val="accent1"/>
-          </a:effectRef>
-          <a:fontRef idx="minor">
-            <a:schemeClr val="tx1"/>
-          </a:fontRef>
-        </p:style>
-        <p:txBody>
-          <a:bodyPr rtlCol="0" anchor="ctr"/>
-          <a:lstStyle/>
-          <a:p>
-            <a:pPr algn="ctr"/>
-            <a:endParaRPr lang="zh-CN" altLang="en-US"/>
-          </a:p>
-        </p:txBody>
-      </p:sp>
-      <p:sp>
-        <p:nvSpPr>
-          <p:cNvPr id="8" name="右箭头 7"/>
-          <p:cNvSpPr/>
-          <p:nvPr/>
-        </p:nvSpPr>
-        <p:spPr>
-          <a:xfrm>
-            <a:off x="5215103" y="4392101"/>
-            <a:ext cx="720080" cy="144016"/>
-          </a:xfrm>
-          <a:prstGeom prst="rightArrow">
-            <a:avLst/>
-          </a:prstGeom>
-        </p:spPr>
-        <p:style>
-          <a:lnRef idx="2">
-            <a:schemeClr val="accent1">
-              <a:shade val="50000"/>
-            </a:schemeClr>
-          </a:lnRef>
-          <a:fillRef idx="1">
-            <a:schemeClr val="accent1"/>
-          </a:fillRef>
-          <a:effectRef idx="0">
-            <a:schemeClr val="accent1"/>
-          </a:effectRef>
-          <a:fontRef idx="minor">
-            <a:schemeClr val="lt1"/>
-          </a:fontRef>
-        </p:style>
-        <p:txBody>
-          <a:bodyPr rtlCol="0" anchor="ctr"/>
-          <a:lstStyle/>
-          <a:p>
-            <a:pPr algn="ctr"/>
-            <a:endParaRPr lang="zh-CN" altLang="en-US"/>
-          </a:p>
-        </p:txBody>
-      </p:sp>
-      <p:sp>
-        <p:nvSpPr>
-          <p:cNvPr id="9" name="右箭头 8"/>
-          <p:cNvSpPr/>
-          <p:nvPr/>
-        </p:nvSpPr>
-        <p:spPr>
-          <a:xfrm>
-            <a:off x="2859809" y="4392101"/>
-            <a:ext cx="539552" cy="72008"/>
-          </a:xfrm>
-          <a:prstGeom prst="rightArrow">
-            <a:avLst/>
-          </a:prstGeom>
-        </p:spPr>
-        <p:style>
-          <a:lnRef idx="2">
-            <a:schemeClr val="accent1">
-              <a:shade val="50000"/>
-            </a:schemeClr>
-          </a:lnRef>
-          <a:fillRef idx="1">
-            <a:schemeClr val="accent1"/>
-          </a:fillRef>
-          <a:effectRef idx="0">
-            <a:schemeClr val="accent1"/>
-          </a:effectRef>
-          <a:fontRef idx="minor">
-            <a:schemeClr val="lt1"/>
-          </a:fontRef>
-        </p:style>
-        <p:txBody>
-          <a:bodyPr rtlCol="0" anchor="ctr"/>
-          <a:lstStyle/>
-          <a:p>
-            <a:pPr algn="ctr"/>
-            <a:endParaRPr lang="zh-CN" altLang="en-US"/>
-          </a:p>
-        </p:txBody>
-      </p:sp>
-      <p:sp>
-        <p:nvSpPr>
-          <p:cNvPr id="10" name="TextBox 9"/>
-          <p:cNvSpPr txBox="1"/>
-          <p:nvPr/>
-        </p:nvSpPr>
-        <p:spPr>
-          <a:xfrm>
-            <a:off x="2779556" y="4067780"/>
-            <a:ext cx="699569" cy="369332"/>
-          </a:xfrm>
-          <a:prstGeom prst="rect">
-            <a:avLst/>
-          </a:prstGeom>
-          <a:noFill/>
-        </p:spPr>
-        <p:txBody>
-          <a:bodyPr wrap="square" rtlCol="0">
-            <a:spAutoFit/>
-          </a:bodyPr>
-          <a:lstStyle/>
-          <a:p>
-            <a:r>
-              <a:rPr lang="en-US" altLang="zh-CN" dirty="0"/>
-              <a:t>input</a:t>
-            </a:r>
-            <a:endParaRPr lang="zh-CN" altLang="en-US" dirty="0"/>
-          </a:p>
-        </p:txBody>
-      </p:sp>
-      <p:sp>
-        <p:nvSpPr>
-          <p:cNvPr id="11" name="TextBox 10"/>
-          <p:cNvSpPr txBox="1"/>
-          <p:nvPr/>
-        </p:nvSpPr>
-        <p:spPr>
-          <a:xfrm>
-            <a:off x="6372952" y="2766111"/>
-            <a:ext cx="2793952" cy="3970318"/>
-          </a:xfrm>
-          <a:prstGeom prst="rect">
-            <a:avLst/>
-          </a:prstGeom>
-          <a:noFill/>
-        </p:spPr>
-        <p:txBody>
-          <a:bodyPr wrap="square" rtlCol="0">
-            <a:spAutoFit/>
-          </a:bodyPr>
-          <a:lstStyle/>
-          <a:p>
-            <a:r>
-              <a:rPr lang="en-US" altLang="zh-CN" dirty="0"/>
-              <a:t>.</a:t>
-            </a:r>
-            <a:r>
-              <a:rPr lang="en-US" altLang="zh-CN" dirty="0" err="1"/>
-              <a:t>cds</a:t>
-            </a:r>
-            <a:r>
-              <a:rPr lang="zh-CN" altLang="en-US" dirty="0"/>
-              <a:t> </a:t>
-            </a:r>
-            <a:r>
-              <a:rPr lang="en-US" altLang="zh-CN" dirty="0"/>
-              <a:t>file:</a:t>
-            </a:r>
-            <a:r>
-              <a:rPr lang="zh-CN" altLang="en-US" dirty="0"/>
-              <a:t> </a:t>
-            </a:r>
-            <a:r>
-              <a:rPr lang="en-US" altLang="zh-CN" dirty="0"/>
-              <a:t>SNPs annotation  of CDS region</a:t>
-            </a:r>
-          </a:p>
-          <a:p>
-            <a:r>
-              <a:rPr lang="en-US" altLang="zh-CN" dirty="0"/>
-              <a:t>.UTR file:</a:t>
-            </a:r>
-          </a:p>
-          <a:p>
-            <a:r>
-              <a:rPr lang="en-US" altLang="zh-CN" dirty="0"/>
-              <a:t>. Intergenic</a:t>
-            </a:r>
-            <a:r>
-              <a:rPr lang="zh-CN" altLang="en-US" dirty="0"/>
-              <a:t>  </a:t>
-            </a:r>
-            <a:r>
-              <a:rPr lang="en-US" altLang="zh-CN" dirty="0"/>
-              <a:t>file: </a:t>
-            </a:r>
-          </a:p>
-          <a:p>
-            <a:r>
-              <a:rPr lang="en-US" altLang="zh-CN" dirty="0"/>
-              <a:t>.</a:t>
-            </a:r>
-            <a:r>
-              <a:rPr lang="en-US" altLang="zh-CN" dirty="0" err="1"/>
-              <a:t>utr</a:t>
-            </a:r>
-            <a:r>
-              <a:rPr lang="zh-CN" altLang="en-US" dirty="0"/>
-              <a:t> </a:t>
-            </a:r>
-            <a:r>
-              <a:rPr lang="en-US" altLang="zh-CN" dirty="0"/>
-              <a:t>file :</a:t>
-            </a:r>
-          </a:p>
-          <a:p>
-            <a:r>
-              <a:rPr lang="en-US" altLang="zh-CN" dirty="0"/>
-              <a:t>.intron file:</a:t>
-            </a:r>
-          </a:p>
-          <a:p>
-            <a:r>
-              <a:rPr lang="en-US" altLang="zh-CN" dirty="0"/>
-              <a:t>.</a:t>
-            </a:r>
-            <a:r>
-              <a:rPr lang="en-US" altLang="zh-CN" dirty="0" err="1"/>
-              <a:t>mutcds</a:t>
-            </a:r>
-            <a:r>
-              <a:rPr lang="en-US" altLang="zh-CN" dirty="0"/>
-              <a:t> file</a:t>
-            </a:r>
-            <a:r>
-              <a:rPr lang="zh-CN" altLang="en-US" dirty="0"/>
-              <a:t>：</a:t>
-            </a:r>
-            <a:r>
-              <a:rPr lang="en-US" altLang="zh-CN" dirty="0"/>
-              <a:t>fill mutate SNPs into CDS sequence</a:t>
-            </a:r>
-          </a:p>
-          <a:p>
-            <a:r>
-              <a:rPr lang="en-US" altLang="zh-CN" dirty="0"/>
-              <a:t>.</a:t>
-            </a:r>
-            <a:r>
-              <a:rPr lang="en-US" altLang="zh-CN" dirty="0" err="1"/>
-              <a:t>mutaa</a:t>
-            </a:r>
-            <a:r>
-              <a:rPr lang="en-US" altLang="zh-CN" dirty="0"/>
-              <a:t> file: translate mutate CDS sequence in to amino acid sequence</a:t>
-            </a:r>
-          </a:p>
-          <a:p>
-            <a:r>
-              <a:rPr lang="en-US" altLang="zh-CN" dirty="0"/>
-              <a:t>.</a:t>
-            </a:r>
-            <a:r>
-              <a:rPr lang="en-US" altLang="zh-CN" dirty="0" err="1"/>
-              <a:t>refaa</a:t>
-            </a:r>
-            <a:r>
-              <a:rPr lang="zh-CN" altLang="en-US" dirty="0"/>
-              <a:t> </a:t>
-            </a:r>
-            <a:r>
-              <a:rPr lang="en-US" altLang="zh-CN" dirty="0"/>
-              <a:t>file: original amino acid </a:t>
-            </a:r>
-            <a:r>
-              <a:rPr lang="en-US" altLang="zh-CN" dirty="0" err="1"/>
-              <a:t>sequcenc</a:t>
-            </a:r>
-            <a:r>
-              <a:rPr lang="en-US" altLang="zh-CN" dirty="0"/>
-              <a:t>.</a:t>
-            </a:r>
-          </a:p>
-          <a:p>
-            <a:endParaRPr lang="en-US" altLang="zh-CN" dirty="0"/>
-          </a:p>
-        </p:txBody>
-      </p:sp>
-      <p:sp>
-        <p:nvSpPr>
-          <p:cNvPr id="12" name="TextBox 11"/>
-          <p:cNvSpPr txBox="1"/>
-          <p:nvPr/>
-        </p:nvSpPr>
-        <p:spPr>
-          <a:xfrm>
-            <a:off x="5127553" y="4104939"/>
-            <a:ext cx="869107" cy="369332"/>
-          </a:xfrm>
-          <a:prstGeom prst="rect">
-            <a:avLst/>
-          </a:prstGeom>
-          <a:noFill/>
-        </p:spPr>
-        <p:txBody>
-          <a:bodyPr wrap="square" rtlCol="0">
-            <a:spAutoFit/>
-          </a:bodyPr>
-          <a:lstStyle/>
-          <a:p>
-            <a:r>
-              <a:rPr lang="en-US" altLang="zh-CN" dirty="0"/>
-              <a:t>output</a:t>
-            </a:r>
-            <a:endParaRPr lang="zh-CN" altLang="en-US" dirty="0"/>
-          </a:p>
-        </p:txBody>
-      </p:sp>
-      <p:sp>
-        <p:nvSpPr>
-          <p:cNvPr id="13" name="左大括号 12"/>
-          <p:cNvSpPr/>
-          <p:nvPr/>
-        </p:nvSpPr>
-        <p:spPr>
-          <a:xfrm>
-            <a:off x="5996660" y="3600013"/>
-            <a:ext cx="377145" cy="1800200"/>
-          </a:xfrm>
-          <a:prstGeom prst="leftBrace">
-            <a:avLst/>
-          </a:prstGeom>
-        </p:spPr>
-        <p:style>
-          <a:lnRef idx="1">
-            <a:schemeClr val="accent1"/>
-          </a:lnRef>
-          <a:fillRef idx="0">
-            <a:schemeClr val="accent1"/>
-          </a:fillRef>
-          <a:effectRef idx="0">
-            <a:schemeClr val="accent1"/>
-          </a:effectRef>
-          <a:fontRef idx="minor">
-            <a:schemeClr val="tx1"/>
-          </a:fontRef>
-        </p:style>
-        <p:txBody>
-          <a:bodyPr rtlCol="0" anchor="ctr"/>
-          <a:lstStyle/>
-          <a:p>
-            <a:pPr algn="ctr"/>
-            <a:endParaRPr lang="zh-CN" altLang="en-US"/>
-          </a:p>
-        </p:txBody>
-      </p:sp>
-    </p:spTree>
-    <p:extLst>
-      <p:ext uri="{BB962C8B-B14F-4D97-AF65-F5344CB8AC3E}">
-        <p14:creationId xmlns:p14="http://schemas.microsoft.com/office/powerpoint/2010/main" val="2686708445"/>
-      </p:ext>
-    </p:extLst>
-  </p:cSld>
-  <p:clrMapOvr>
-    <a:masterClrMapping/>
-  </p:clrMapOvr>
-</p:sld>
-</file>
-
 <file path=ppt/slides/slide27.xml><?xml version="1.0" encoding="utf-8"?>
 <p:sld xmlns:a="http://schemas.openxmlformats.org/drawingml/2006/main" xmlns:r="http://schemas.openxmlformats.org/officeDocument/2006/relationships" xmlns:p="http://schemas.openxmlformats.org/presentationml/2006/main">
   <p:cSld>
@@ -11360,6 +10784,709 @@
           <a:p>
             <a:r>
               <a:rPr lang="en-US" altLang="zh-CN" sz="3200" dirty="0"/>
+              <a:t>overview</a:t>
+            </a:r>
+            <a:endParaRPr lang="zh-CN" altLang="en-US" sz="3200" dirty="0"/>
+          </a:p>
+        </p:txBody>
+      </p:sp>
+      <p:sp>
+        <p:nvSpPr>
+          <p:cNvPr id="3" name="内容占位符 2"/>
+          <p:cNvSpPr>
+            <a:spLocks noGrp="1"/>
+          </p:cNvSpPr>
+          <p:nvPr>
+            <p:ph idx="1"/>
+          </p:nvPr>
+        </p:nvSpPr>
+        <p:spPr>
+          <a:xfrm>
+            <a:off x="457200" y="1196752"/>
+            <a:ext cx="8229600" cy="5328592"/>
+          </a:xfrm>
+        </p:spPr>
+        <p:txBody>
+          <a:bodyPr>
+            <a:normAutofit/>
+          </a:bodyPr>
+          <a:lstStyle/>
+          <a:p>
+            <a:r>
+              <a:rPr lang="en-US" altLang="zh-CN" sz="2400" dirty="0"/>
+              <a:t>VCF variant annotation program</a:t>
+            </a:r>
+          </a:p>
+          <a:p>
+            <a:r>
+              <a:rPr lang="en-US" altLang="zh-CN" sz="2400" dirty="0"/>
+              <a:t>Classify SNPs according its location in intron, </a:t>
+            </a:r>
+            <a:r>
+              <a:rPr lang="en-US" altLang="zh-CN" sz="2400" dirty="0" err="1"/>
+              <a:t>utr</a:t>
+            </a:r>
+            <a:r>
+              <a:rPr lang="en-US" altLang="zh-CN" sz="2400" dirty="0"/>
+              <a:t>, </a:t>
+            </a:r>
+            <a:r>
+              <a:rPr lang="en-US" altLang="zh-CN" sz="2400" dirty="0" err="1"/>
+              <a:t>intergenetic</a:t>
+            </a:r>
+            <a:r>
+              <a:rPr lang="en-US" altLang="zh-CN" sz="2400" dirty="0"/>
+              <a:t> or synonymous and </a:t>
+            </a:r>
+            <a:r>
+              <a:rPr lang="en-US" altLang="zh-CN" sz="2400" dirty="0" err="1"/>
+              <a:t>nosynonymous</a:t>
+            </a:r>
+            <a:endParaRPr lang="en-US" altLang="zh-CN" sz="2400" dirty="0"/>
+          </a:p>
+          <a:p>
+            <a:r>
+              <a:rPr lang="en-US" altLang="zh-CN" sz="2400" dirty="0"/>
+              <a:t>Translate mutation CDS into mutation AA </a:t>
+            </a:r>
+            <a:r>
+              <a:rPr lang="en-US" altLang="zh-CN" sz="2400" dirty="0" err="1"/>
+              <a:t>seq</a:t>
+            </a:r>
+            <a:endParaRPr lang="zh-CN" altLang="en-US" sz="2400" dirty="0"/>
+          </a:p>
+        </p:txBody>
+      </p:sp>
+      <p:sp>
+        <p:nvSpPr>
+          <p:cNvPr id="4" name="TextBox 3"/>
+          <p:cNvSpPr txBox="1"/>
+          <p:nvPr/>
+        </p:nvSpPr>
+        <p:spPr>
+          <a:xfrm>
+            <a:off x="0" y="0"/>
+            <a:ext cx="9139472" cy="369332"/>
+          </a:xfrm>
+          <a:prstGeom prst="rect">
+            <a:avLst/>
+          </a:prstGeom>
+          <a:noFill/>
+        </p:spPr>
+        <p:txBody>
+          <a:bodyPr wrap="square" rtlCol="0">
+            <a:spAutoFit/>
+          </a:bodyPr>
+          <a:lstStyle/>
+          <a:p>
+            <a:r>
+              <a:rPr lang="en-US" altLang="zh-CN" dirty="0"/>
+              <a:t>CatalogSNP_getAAseq_CDSseq.py</a:t>
+            </a:r>
+            <a:endParaRPr lang="zh-CN" altLang="en-US" dirty="0"/>
+          </a:p>
+        </p:txBody>
+      </p:sp>
+      <p:sp>
+        <p:nvSpPr>
+          <p:cNvPr id="5" name="矩形 4"/>
+          <p:cNvSpPr/>
+          <p:nvPr/>
+        </p:nvSpPr>
+        <p:spPr>
+          <a:xfrm>
+            <a:off x="3399361" y="3816037"/>
+            <a:ext cx="1728192" cy="1152128"/>
+          </a:xfrm>
+          <a:prstGeom prst="rect">
+            <a:avLst/>
+          </a:prstGeom>
+          <a:solidFill>
+            <a:schemeClr val="accent1">
+              <a:alpha val="0"/>
+            </a:schemeClr>
+          </a:solidFill>
+        </p:spPr>
+        <p:style>
+          <a:lnRef idx="2">
+            <a:schemeClr val="accent1">
+              <a:shade val="50000"/>
+            </a:schemeClr>
+          </a:lnRef>
+          <a:fillRef idx="1">
+            <a:schemeClr val="accent1"/>
+          </a:fillRef>
+          <a:effectRef idx="0">
+            <a:schemeClr val="accent1"/>
+          </a:effectRef>
+          <a:fontRef idx="minor">
+            <a:schemeClr val="lt1"/>
+          </a:fontRef>
+        </p:style>
+        <p:txBody>
+          <a:bodyPr rtlCol="0" anchor="ctr"/>
+          <a:lstStyle/>
+          <a:p>
+            <a:pPr algn="ctr"/>
+            <a:r>
+              <a:rPr lang="en-US" altLang="zh-CN" dirty="0">
+                <a:solidFill>
+                  <a:schemeClr val="tx1"/>
+                </a:solidFill>
+              </a:rPr>
+              <a:t>CatalogSNP_withaaseq_cdsseq.py</a:t>
+            </a:r>
+            <a:endParaRPr lang="zh-CN" altLang="en-US" dirty="0">
+              <a:solidFill>
+                <a:schemeClr val="tx1"/>
+              </a:solidFill>
+            </a:endParaRPr>
+          </a:p>
+        </p:txBody>
+      </p:sp>
+      <p:sp>
+        <p:nvSpPr>
+          <p:cNvPr id="6" name="TextBox 5"/>
+          <p:cNvSpPr txBox="1"/>
+          <p:nvPr/>
+        </p:nvSpPr>
+        <p:spPr>
+          <a:xfrm>
+            <a:off x="0" y="2970232"/>
+            <a:ext cx="2928571" cy="4247317"/>
+          </a:xfrm>
+          <a:prstGeom prst="rect">
+            <a:avLst/>
+          </a:prstGeom>
+          <a:noFill/>
+        </p:spPr>
+        <p:txBody>
+          <a:bodyPr wrap="square" rtlCol="0">
+            <a:spAutoFit/>
+          </a:bodyPr>
+          <a:lstStyle/>
+          <a:p>
+            <a:r>
+              <a:rPr lang="en-US" altLang="zh-CN" dirty="0"/>
+              <a:t>-v SNPs </a:t>
+            </a:r>
+            <a:r>
+              <a:rPr lang="en-US" altLang="zh-CN" dirty="0" err="1"/>
+              <a:t>mysql</a:t>
+            </a:r>
+            <a:r>
+              <a:rPr lang="zh-CN" altLang="en-US" dirty="0"/>
+              <a:t> </a:t>
+            </a:r>
+            <a:r>
+              <a:rPr lang="en-US" altLang="zh-CN" dirty="0"/>
+              <a:t>table name</a:t>
+            </a:r>
+          </a:p>
+          <a:p>
+            <a:r>
+              <a:rPr lang="en-US" altLang="zh-CN" dirty="0"/>
+              <a:t>-V VCF file name</a:t>
+            </a:r>
+          </a:p>
+          <a:p>
+            <a:r>
+              <a:rPr lang="en-US" altLang="zh-CN" dirty="0"/>
+              <a:t>-r reference </a:t>
+            </a:r>
+            <a:r>
+              <a:rPr lang="en-US" altLang="zh-CN" dirty="0" err="1"/>
+              <a:t>fasta</a:t>
+            </a:r>
+            <a:r>
+              <a:rPr lang="en-US" altLang="zh-CN" dirty="0"/>
+              <a:t> file</a:t>
+            </a:r>
+          </a:p>
+          <a:p>
+            <a:r>
+              <a:rPr lang="en-US" altLang="zh-CN" dirty="0"/>
+              <a:t>-g GTF file</a:t>
+            </a:r>
+          </a:p>
+          <a:p>
+            <a:r>
+              <a:rPr lang="en-US" altLang="zh-CN" dirty="0"/>
+              <a:t>-o output path</a:t>
+            </a:r>
+          </a:p>
+          <a:p>
+            <a:r>
+              <a:rPr lang="en-US" altLang="zh-CN" dirty="0"/>
+              <a:t>-b bed</a:t>
+            </a:r>
+            <a:r>
+              <a:rPr lang="zh-CN" altLang="en-US" dirty="0"/>
+              <a:t> </a:t>
+            </a:r>
+            <a:r>
+              <a:rPr lang="en-US" altLang="zh-CN" dirty="0"/>
+              <a:t>file</a:t>
+            </a:r>
+            <a:r>
+              <a:rPr lang="zh-CN" altLang="en-US" dirty="0"/>
+              <a:t>（</a:t>
+            </a:r>
+            <a:r>
+              <a:rPr lang="en-US" altLang="zh-CN" dirty="0"/>
+              <a:t>…</a:t>
+            </a:r>
+            <a:r>
+              <a:rPr lang="en-US" altLang="zh-CN" dirty="0" err="1"/>
+              <a:t>ing</a:t>
+            </a:r>
+            <a:r>
+              <a:rPr lang="zh-CN" altLang="en-US" dirty="0"/>
+              <a:t>）</a:t>
+            </a:r>
+            <a:endParaRPr lang="en-US" altLang="zh-CN" dirty="0"/>
+          </a:p>
+          <a:p>
+            <a:r>
+              <a:rPr lang="en-US" altLang="zh-CN" dirty="0"/>
+              <a:t>-m min length of the scaffolds (for –v only)</a:t>
+            </a:r>
+          </a:p>
+          <a:p>
+            <a:r>
+              <a:rPr lang="en-US" altLang="zh-CN" dirty="0"/>
+              <a:t>-5,-3 define distance from the start/stop codon as 5’/3’ UTR, in the case UTR annotation are absent in GTF annotation </a:t>
+            </a:r>
+          </a:p>
+          <a:p>
+            <a:endParaRPr lang="en-US" altLang="zh-CN" dirty="0"/>
+          </a:p>
+          <a:p>
+            <a:endParaRPr lang="zh-CN" altLang="en-US" dirty="0"/>
+          </a:p>
+        </p:txBody>
+      </p:sp>
+      <p:sp>
+        <p:nvSpPr>
+          <p:cNvPr id="7" name="右大括号 6"/>
+          <p:cNvSpPr/>
+          <p:nvPr/>
+        </p:nvSpPr>
+        <p:spPr>
+          <a:xfrm>
+            <a:off x="2555776" y="3816037"/>
+            <a:ext cx="432048" cy="1152128"/>
+          </a:xfrm>
+          <a:prstGeom prst="rightBrace">
+            <a:avLst/>
+          </a:prstGeom>
+        </p:spPr>
+        <p:style>
+          <a:lnRef idx="1">
+            <a:schemeClr val="accent1"/>
+          </a:lnRef>
+          <a:fillRef idx="0">
+            <a:schemeClr val="accent1"/>
+          </a:fillRef>
+          <a:effectRef idx="0">
+            <a:schemeClr val="accent1"/>
+          </a:effectRef>
+          <a:fontRef idx="minor">
+            <a:schemeClr val="tx1"/>
+          </a:fontRef>
+        </p:style>
+        <p:txBody>
+          <a:bodyPr rtlCol="0" anchor="ctr"/>
+          <a:lstStyle/>
+          <a:p>
+            <a:pPr algn="ctr"/>
+            <a:endParaRPr lang="zh-CN" altLang="en-US"/>
+          </a:p>
+        </p:txBody>
+      </p:sp>
+      <p:sp>
+        <p:nvSpPr>
+          <p:cNvPr id="8" name="右箭头 7"/>
+          <p:cNvSpPr/>
+          <p:nvPr/>
+        </p:nvSpPr>
+        <p:spPr>
+          <a:xfrm>
+            <a:off x="5215103" y="4392101"/>
+            <a:ext cx="720080" cy="144016"/>
+          </a:xfrm>
+          <a:prstGeom prst="rightArrow">
+            <a:avLst/>
+          </a:prstGeom>
+        </p:spPr>
+        <p:style>
+          <a:lnRef idx="2">
+            <a:schemeClr val="accent1">
+              <a:shade val="50000"/>
+            </a:schemeClr>
+          </a:lnRef>
+          <a:fillRef idx="1">
+            <a:schemeClr val="accent1"/>
+          </a:fillRef>
+          <a:effectRef idx="0">
+            <a:schemeClr val="accent1"/>
+          </a:effectRef>
+          <a:fontRef idx="minor">
+            <a:schemeClr val="lt1"/>
+          </a:fontRef>
+        </p:style>
+        <p:txBody>
+          <a:bodyPr rtlCol="0" anchor="ctr"/>
+          <a:lstStyle/>
+          <a:p>
+            <a:pPr algn="ctr"/>
+            <a:endParaRPr lang="zh-CN" altLang="en-US"/>
+          </a:p>
+        </p:txBody>
+      </p:sp>
+      <p:sp>
+        <p:nvSpPr>
+          <p:cNvPr id="9" name="右箭头 8"/>
+          <p:cNvSpPr/>
+          <p:nvPr/>
+        </p:nvSpPr>
+        <p:spPr>
+          <a:xfrm>
+            <a:off x="2859809" y="4392101"/>
+            <a:ext cx="539552" cy="72008"/>
+          </a:xfrm>
+          <a:prstGeom prst="rightArrow">
+            <a:avLst/>
+          </a:prstGeom>
+        </p:spPr>
+        <p:style>
+          <a:lnRef idx="2">
+            <a:schemeClr val="accent1">
+              <a:shade val="50000"/>
+            </a:schemeClr>
+          </a:lnRef>
+          <a:fillRef idx="1">
+            <a:schemeClr val="accent1"/>
+          </a:fillRef>
+          <a:effectRef idx="0">
+            <a:schemeClr val="accent1"/>
+          </a:effectRef>
+          <a:fontRef idx="minor">
+            <a:schemeClr val="lt1"/>
+          </a:fontRef>
+        </p:style>
+        <p:txBody>
+          <a:bodyPr rtlCol="0" anchor="ctr"/>
+          <a:lstStyle/>
+          <a:p>
+            <a:pPr algn="ctr"/>
+            <a:endParaRPr lang="zh-CN" altLang="en-US"/>
+          </a:p>
+        </p:txBody>
+      </p:sp>
+      <p:sp>
+        <p:nvSpPr>
+          <p:cNvPr id="10" name="TextBox 9"/>
+          <p:cNvSpPr txBox="1"/>
+          <p:nvPr/>
+        </p:nvSpPr>
+        <p:spPr>
+          <a:xfrm>
+            <a:off x="2779556" y="4067780"/>
+            <a:ext cx="699569" cy="369332"/>
+          </a:xfrm>
+          <a:prstGeom prst="rect">
+            <a:avLst/>
+          </a:prstGeom>
+          <a:noFill/>
+        </p:spPr>
+        <p:txBody>
+          <a:bodyPr wrap="square" rtlCol="0">
+            <a:spAutoFit/>
+          </a:bodyPr>
+          <a:lstStyle/>
+          <a:p>
+            <a:r>
+              <a:rPr lang="en-US" altLang="zh-CN" dirty="0"/>
+              <a:t>input</a:t>
+            </a:r>
+            <a:endParaRPr lang="zh-CN" altLang="en-US" dirty="0"/>
+          </a:p>
+        </p:txBody>
+      </p:sp>
+      <p:sp>
+        <p:nvSpPr>
+          <p:cNvPr id="11" name="TextBox 10"/>
+          <p:cNvSpPr txBox="1"/>
+          <p:nvPr/>
+        </p:nvSpPr>
+        <p:spPr>
+          <a:xfrm>
+            <a:off x="6372952" y="2766111"/>
+            <a:ext cx="2793952" cy="3970318"/>
+          </a:xfrm>
+          <a:prstGeom prst="rect">
+            <a:avLst/>
+          </a:prstGeom>
+          <a:noFill/>
+        </p:spPr>
+        <p:txBody>
+          <a:bodyPr wrap="square" rtlCol="0">
+            <a:spAutoFit/>
+          </a:bodyPr>
+          <a:lstStyle/>
+          <a:p>
+            <a:r>
+              <a:rPr lang="en-US" altLang="zh-CN" dirty="0"/>
+              <a:t>.</a:t>
+            </a:r>
+            <a:r>
+              <a:rPr lang="en-US" altLang="zh-CN" dirty="0" err="1"/>
+              <a:t>cds</a:t>
+            </a:r>
+            <a:r>
+              <a:rPr lang="zh-CN" altLang="en-US" dirty="0"/>
+              <a:t> </a:t>
+            </a:r>
+            <a:r>
+              <a:rPr lang="en-US" altLang="zh-CN" dirty="0"/>
+              <a:t>file:</a:t>
+            </a:r>
+            <a:r>
+              <a:rPr lang="zh-CN" altLang="en-US" dirty="0"/>
+              <a:t> </a:t>
+            </a:r>
+            <a:r>
+              <a:rPr lang="en-US" altLang="zh-CN" dirty="0"/>
+              <a:t>SNPs annotation  of CDS region</a:t>
+            </a:r>
+          </a:p>
+          <a:p>
+            <a:r>
+              <a:rPr lang="en-US" altLang="zh-CN" dirty="0"/>
+              <a:t>.UTR file:</a:t>
+            </a:r>
+          </a:p>
+          <a:p>
+            <a:r>
+              <a:rPr lang="en-US" altLang="zh-CN" dirty="0"/>
+              <a:t>. Intergenic</a:t>
+            </a:r>
+            <a:r>
+              <a:rPr lang="zh-CN" altLang="en-US" dirty="0"/>
+              <a:t>  </a:t>
+            </a:r>
+            <a:r>
+              <a:rPr lang="en-US" altLang="zh-CN" dirty="0"/>
+              <a:t>file: </a:t>
+            </a:r>
+          </a:p>
+          <a:p>
+            <a:r>
+              <a:rPr lang="en-US" altLang="zh-CN" dirty="0"/>
+              <a:t>.</a:t>
+            </a:r>
+            <a:r>
+              <a:rPr lang="en-US" altLang="zh-CN" dirty="0" err="1"/>
+              <a:t>utr</a:t>
+            </a:r>
+            <a:r>
+              <a:rPr lang="zh-CN" altLang="en-US" dirty="0"/>
+              <a:t> </a:t>
+            </a:r>
+            <a:r>
+              <a:rPr lang="en-US" altLang="zh-CN" dirty="0"/>
+              <a:t>file :</a:t>
+            </a:r>
+          </a:p>
+          <a:p>
+            <a:r>
+              <a:rPr lang="en-US" altLang="zh-CN" dirty="0"/>
+              <a:t>.intron file:</a:t>
+            </a:r>
+          </a:p>
+          <a:p>
+            <a:r>
+              <a:rPr lang="en-US" altLang="zh-CN" dirty="0"/>
+              <a:t>.</a:t>
+            </a:r>
+            <a:r>
+              <a:rPr lang="en-US" altLang="zh-CN" dirty="0" err="1"/>
+              <a:t>mutcds</a:t>
+            </a:r>
+            <a:r>
+              <a:rPr lang="en-US" altLang="zh-CN" dirty="0"/>
+              <a:t> file</a:t>
+            </a:r>
+            <a:r>
+              <a:rPr lang="zh-CN" altLang="en-US" dirty="0"/>
+              <a:t>：</a:t>
+            </a:r>
+            <a:r>
+              <a:rPr lang="en-US" altLang="zh-CN" dirty="0"/>
+              <a:t>fill mutate SNPs into CDS sequence</a:t>
+            </a:r>
+          </a:p>
+          <a:p>
+            <a:r>
+              <a:rPr lang="en-US" altLang="zh-CN" dirty="0"/>
+              <a:t>.</a:t>
+            </a:r>
+            <a:r>
+              <a:rPr lang="en-US" altLang="zh-CN" dirty="0" err="1"/>
+              <a:t>mutaa</a:t>
+            </a:r>
+            <a:r>
+              <a:rPr lang="en-US" altLang="zh-CN" dirty="0"/>
+              <a:t> file: translate mutate CDS sequence in to amino acid sequence</a:t>
+            </a:r>
+          </a:p>
+          <a:p>
+            <a:r>
+              <a:rPr lang="en-US" altLang="zh-CN" dirty="0"/>
+              <a:t>.</a:t>
+            </a:r>
+            <a:r>
+              <a:rPr lang="en-US" altLang="zh-CN" dirty="0" err="1"/>
+              <a:t>refaa</a:t>
+            </a:r>
+            <a:r>
+              <a:rPr lang="zh-CN" altLang="en-US" dirty="0"/>
+              <a:t> </a:t>
+            </a:r>
+            <a:r>
+              <a:rPr lang="en-US" altLang="zh-CN" dirty="0"/>
+              <a:t>file: original amino acid </a:t>
+            </a:r>
+            <a:r>
+              <a:rPr lang="en-US" altLang="zh-CN" dirty="0" err="1"/>
+              <a:t>sequcenc</a:t>
+            </a:r>
+            <a:r>
+              <a:rPr lang="en-US" altLang="zh-CN" dirty="0"/>
+              <a:t>.</a:t>
+            </a:r>
+          </a:p>
+          <a:p>
+            <a:endParaRPr lang="en-US" altLang="zh-CN" dirty="0"/>
+          </a:p>
+        </p:txBody>
+      </p:sp>
+      <p:sp>
+        <p:nvSpPr>
+          <p:cNvPr id="12" name="TextBox 11"/>
+          <p:cNvSpPr txBox="1"/>
+          <p:nvPr/>
+        </p:nvSpPr>
+        <p:spPr>
+          <a:xfrm>
+            <a:off x="5127553" y="4104939"/>
+            <a:ext cx="869107" cy="369332"/>
+          </a:xfrm>
+          <a:prstGeom prst="rect">
+            <a:avLst/>
+          </a:prstGeom>
+          <a:noFill/>
+        </p:spPr>
+        <p:txBody>
+          <a:bodyPr wrap="square" rtlCol="0">
+            <a:spAutoFit/>
+          </a:bodyPr>
+          <a:lstStyle/>
+          <a:p>
+            <a:r>
+              <a:rPr lang="en-US" altLang="zh-CN" dirty="0"/>
+              <a:t>output</a:t>
+            </a:r>
+            <a:endParaRPr lang="zh-CN" altLang="en-US" dirty="0"/>
+          </a:p>
+        </p:txBody>
+      </p:sp>
+      <p:sp>
+        <p:nvSpPr>
+          <p:cNvPr id="13" name="左大括号 12"/>
+          <p:cNvSpPr/>
+          <p:nvPr/>
+        </p:nvSpPr>
+        <p:spPr>
+          <a:xfrm>
+            <a:off x="5996660" y="3600013"/>
+            <a:ext cx="377145" cy="1800200"/>
+          </a:xfrm>
+          <a:prstGeom prst="leftBrace">
+            <a:avLst/>
+          </a:prstGeom>
+        </p:spPr>
+        <p:style>
+          <a:lnRef idx="1">
+            <a:schemeClr val="accent1"/>
+          </a:lnRef>
+          <a:fillRef idx="0">
+            <a:schemeClr val="accent1"/>
+          </a:fillRef>
+          <a:effectRef idx="0">
+            <a:schemeClr val="accent1"/>
+          </a:effectRef>
+          <a:fontRef idx="minor">
+            <a:schemeClr val="tx1"/>
+          </a:fontRef>
+        </p:style>
+        <p:txBody>
+          <a:bodyPr rtlCol="0" anchor="ctr"/>
+          <a:lstStyle/>
+          <a:p>
+            <a:pPr algn="ctr"/>
+            <a:endParaRPr lang="zh-CN" altLang="en-US"/>
+          </a:p>
+        </p:txBody>
+      </p:sp>
+    </p:spTree>
+    <p:extLst>
+      <p:ext uri="{BB962C8B-B14F-4D97-AF65-F5344CB8AC3E}">
+        <p14:creationId xmlns:p14="http://schemas.microsoft.com/office/powerpoint/2010/main" val="2686708445"/>
+      </p:ext>
+    </p:extLst>
+  </p:cSld>
+  <p:clrMapOvr>
+    <a:masterClrMapping/>
+  </p:clrMapOvr>
+</p:sld>
+</file>
+
+<file path=ppt/slides/slide28.xml><?xml version="1.0" encoding="utf-8"?>
+<p:sld xmlns:a="http://schemas.openxmlformats.org/drawingml/2006/main" xmlns:r="http://schemas.openxmlformats.org/officeDocument/2006/relationships" xmlns:p="http://schemas.openxmlformats.org/presentationml/2006/main">
+  <p:cSld>
+    <p:spTree>
+      <p:nvGrpSpPr>
+        <p:cNvPr id="1" name=""/>
+        <p:cNvGrpSpPr/>
+        <p:nvPr/>
+      </p:nvGrpSpPr>
+      <p:grpSpPr>
+        <a:xfrm>
+          <a:off x="0" y="0"/>
+          <a:ext cx="0" cy="0"/>
+          <a:chOff x="0" y="0"/>
+          <a:chExt cx="0" cy="0"/>
+        </a:xfrm>
+      </p:grpSpPr>
+      <p:sp>
+        <p:nvSpPr>
+          <p:cNvPr id="2" name="标题 1"/>
+          <p:cNvSpPr>
+            <a:spLocks noGrp="1"/>
+          </p:cNvSpPr>
+          <p:nvPr>
+            <p:ph type="title"/>
+          </p:nvPr>
+        </p:nvSpPr>
+        <p:spPr/>
+        <p:txBody>
+          <a:bodyPr/>
+          <a:lstStyle/>
+          <a:p>
+            <a:r>
+              <a:rPr lang="en-US" altLang="zh-CN" sz="3200" dirty="0"/>
               <a:t>GO enrichment analysis were implemented in </a:t>
             </a:r>
             <a:r>
@@ -11452,7 +11579,7 @@
 </p:sld>
 </file>
 
-<file path=ppt/slides/slide28.xml><?xml version="1.0" encoding="utf-8"?>
+<file path=ppt/slides/slide29.xml><?xml version="1.0" encoding="utf-8"?>
 <p:sld xmlns:a="http://schemas.openxmlformats.org/drawingml/2006/main" xmlns:r="http://schemas.openxmlformats.org/officeDocument/2006/relationships" xmlns:p="http://schemas.openxmlformats.org/presentationml/2006/main">
   <p:cSld>
     <p:spTree>

</xml_diff>